<commit_message>
Updated the presentation file
</commit_message>
<xml_diff>
--- a/documentation/Zephyr_STM32_VL53L8CX.pptx
+++ b/documentation/Zephyr_STM32_VL53L8CX.pptx
@@ -5,7 +5,7 @@
     <p:sldMasterId id="2147483648" r:id="rId1"/>
   </p:sldMasterIdLst>
   <p:notesMasterIdLst>
-    <p:notesMasterId r:id="rId20"/>
+    <p:notesMasterId r:id="rId21"/>
   </p:notesMasterIdLst>
   <p:sldIdLst>
     <p:sldId id="274" r:id="rId2"/>
@@ -23,9 +23,10 @@
     <p:sldId id="267" r:id="rId14"/>
     <p:sldId id="279" r:id="rId15"/>
     <p:sldId id="282" r:id="rId16"/>
-    <p:sldId id="270" r:id="rId17"/>
+    <p:sldId id="285" r:id="rId17"/>
     <p:sldId id="271" r:id="rId18"/>
     <p:sldId id="272" r:id="rId19"/>
+    <p:sldId id="286" r:id="rId20"/>
   </p:sldIdLst>
   <p:sldSz cx="12192000" cy="6858000"/>
   <p:notesSz cx="6858000" cy="9144000"/>
@@ -225,7 +226,7 @@
           <a:p>
             <a:fld id="{AF9759F7-8281-4303-863A-322F1831FDC0}" type="datetimeFigureOut">
               <a:rPr lang="en-US" smtClean="0"/>
-              <a:t>9/15/2026</a:t>
+              <a:t>9/16/2026</a:t>
             </a:fld>
             <a:endParaRPr lang="en-US"/>
           </a:p>
@@ -839,7 +840,7 @@
           <a:p>
             <a:fld id="{5BCAD085-E8A6-8845-BD4E-CB4CCA059FC4}" type="datetimeFigureOut">
               <a:rPr lang="en-US" smtClean="0"/>
-              <a:t>9/15/2026</a:t>
+              <a:t>9/16/2026</a:t>
             </a:fld>
             <a:endParaRPr lang="en-US"/>
           </a:p>
@@ -1007,7 +1008,7 @@
           <a:p>
             <a:fld id="{5BCAD085-E8A6-8845-BD4E-CB4CCA059FC4}" type="datetimeFigureOut">
               <a:rPr lang="en-US" smtClean="0"/>
-              <a:t>9/15/2026</a:t>
+              <a:t>9/16/2026</a:t>
             </a:fld>
             <a:endParaRPr lang="en-US"/>
           </a:p>
@@ -1185,7 +1186,7 @@
           <a:p>
             <a:fld id="{5BCAD085-E8A6-8845-BD4E-CB4CCA059FC4}" type="datetimeFigureOut">
               <a:rPr lang="en-US" smtClean="0"/>
-              <a:t>9/15/2026</a:t>
+              <a:t>9/16/2026</a:t>
             </a:fld>
             <a:endParaRPr lang="en-US"/>
           </a:p>
@@ -1388,7 +1389,7 @@
           <a:p>
             <a:fld id="{5BCAD085-E8A6-8845-BD4E-CB4CCA059FC4}" type="datetimeFigureOut">
               <a:rPr lang="en-US" smtClean="0"/>
-              <a:t>9/15/2026</a:t>
+              <a:t>9/16/2026</a:t>
             </a:fld>
             <a:endParaRPr lang="en-US"/>
           </a:p>
@@ -1633,7 +1634,7 @@
           <a:p>
             <a:fld id="{5BCAD085-E8A6-8845-BD4E-CB4CCA059FC4}" type="datetimeFigureOut">
               <a:rPr lang="en-US" smtClean="0"/>
-              <a:t>9/15/2026</a:t>
+              <a:t>9/16/2026</a:t>
             </a:fld>
             <a:endParaRPr lang="en-US"/>
           </a:p>
@@ -1918,7 +1919,7 @@
           <a:p>
             <a:fld id="{5BCAD085-E8A6-8845-BD4E-CB4CCA059FC4}" type="datetimeFigureOut">
               <a:rPr lang="en-US" smtClean="0"/>
-              <a:t>9/15/2026</a:t>
+              <a:t>9/16/2026</a:t>
             </a:fld>
             <a:endParaRPr lang="en-US"/>
           </a:p>
@@ -2337,7 +2338,7 @@
           <a:p>
             <a:fld id="{5BCAD085-E8A6-8845-BD4E-CB4CCA059FC4}" type="datetimeFigureOut">
               <a:rPr lang="en-US" smtClean="0"/>
-              <a:t>9/15/2026</a:t>
+              <a:t>9/16/2026</a:t>
             </a:fld>
             <a:endParaRPr lang="en-US"/>
           </a:p>
@@ -2454,7 +2455,7 @@
           <a:p>
             <a:fld id="{5BCAD085-E8A6-8845-BD4E-CB4CCA059FC4}" type="datetimeFigureOut">
               <a:rPr lang="en-US" smtClean="0"/>
-              <a:t>9/15/2026</a:t>
+              <a:t>9/16/2026</a:t>
             </a:fld>
             <a:endParaRPr lang="en-US"/>
           </a:p>
@@ -2549,7 +2550,7 @@
           <a:p>
             <a:fld id="{5BCAD085-E8A6-8845-BD4E-CB4CCA059FC4}" type="datetimeFigureOut">
               <a:rPr lang="en-US" smtClean="0"/>
-              <a:t>9/15/2026</a:t>
+              <a:t>9/16/2026</a:t>
             </a:fld>
             <a:endParaRPr lang="en-US"/>
           </a:p>
@@ -2824,7 +2825,7 @@
           <a:p>
             <a:fld id="{5BCAD085-E8A6-8845-BD4E-CB4CCA059FC4}" type="datetimeFigureOut">
               <a:rPr lang="en-US" smtClean="0"/>
-              <a:t>9/15/2026</a:t>
+              <a:t>9/16/2026</a:t>
             </a:fld>
             <a:endParaRPr lang="en-US"/>
           </a:p>
@@ -3076,7 +3077,7 @@
           <a:p>
             <a:fld id="{5BCAD085-E8A6-8845-BD4E-CB4CCA059FC4}" type="datetimeFigureOut">
               <a:rPr lang="en-US" smtClean="0"/>
-              <a:t>9/15/2026</a:t>
+              <a:t>9/16/2026</a:t>
             </a:fld>
             <a:endParaRPr lang="en-US"/>
           </a:p>
@@ -3287,7 +3288,7 @@
           <a:p>
             <a:fld id="{5BCAD085-E8A6-8845-BD4E-CB4CCA059FC4}" type="datetimeFigureOut">
               <a:rPr lang="en-US" smtClean="0"/>
-              <a:t>9/15/2026</a:t>
+              <a:t>9/16/2026</a:t>
             </a:fld>
             <a:endParaRPr lang="en-US"/>
           </a:p>
@@ -7647,55 +7648,6 @@
       </p:sp>
       <p:sp>
         <p:nvSpPr>
-          <p:cNvPr id="4" name="Rounded Rectangle 3"/>
-          <p:cNvSpPr/>
-          <p:nvPr/>
-        </p:nvSpPr>
-        <p:spPr>
-          <a:xfrm>
-            <a:off x="640080" y="1243584"/>
-            <a:ext cx="822960" cy="36576"/>
-          </a:xfrm>
-          <a:prstGeom prst="roundRect">
-            <a:avLst>
-              <a:gd name="adj" fmla="val 50000"/>
-            </a:avLst>
-          </a:prstGeom>
-          <a:solidFill>
-            <a:srgbClr val="2563EB"/>
-          </a:solidFill>
-          <a:ln>
-            <a:noFill/>
-          </a:ln>
-          <a:effectLst/>
-        </p:spPr>
-        <p:style>
-          <a:lnRef idx="1">
-            <a:schemeClr val="accent1"/>
-          </a:lnRef>
-          <a:fillRef idx="3">
-            <a:schemeClr val="accent1"/>
-          </a:fillRef>
-          <a:effectRef idx="2">
-            <a:schemeClr val="accent1"/>
-          </a:effectRef>
-          <a:fontRef idx="minor">
-            <a:schemeClr val="lt1"/>
-          </a:fontRef>
-        </p:style>
-        <p:txBody>
-          <a:bodyPr rtlCol="0" anchor="ctr"/>
-          <a:lstStyle/>
-          <a:p>
-            <a:pPr algn="ctr"/>
-            <a:endParaRPr>
-              <a:latin typeface="Rockwell" panose="02060603020205020403" pitchFamily="18" charset="0"/>
-            </a:endParaRPr>
-          </a:p>
-        </p:txBody>
-      </p:sp>
-      <p:sp>
-        <p:nvSpPr>
           <p:cNvPr id="7" name="Rounded Rectangle 6"/>
           <p:cNvSpPr/>
           <p:nvPr/>
@@ -9090,14 +9042,20 @@
       </p:grpSpPr>
       <p:sp>
         <p:nvSpPr>
-          <p:cNvPr id="2" name="TextBox 1"/>
+          <p:cNvPr id="2" name="TextBox 1">
+            <a:extLst>
+              <a:ext uri="{FF2B5EF4-FFF2-40B4-BE49-F238E27FC236}">
+                <a16:creationId xmlns:a16="http://schemas.microsoft.com/office/drawing/2014/main" id="{D3DEB0BE-70E1-4874-9D91-4FAC356E684B}"/>
+              </a:ext>
+            </a:extLst>
+          </p:cNvPr>
           <p:cNvSpPr txBox="1"/>
           <p:nvPr/>
         </p:nvSpPr>
         <p:spPr>
           <a:xfrm>
-            <a:off x="640080" y="365760"/>
-            <a:ext cx="7315200" cy="320040"/>
+            <a:off x="635000" y="330200"/>
+            <a:ext cx="6350000" cy="254000"/>
           </a:xfrm>
           <a:prstGeom prst="rect">
             <a:avLst/>
@@ -9105,38 +9063,40 @@
           <a:noFill/>
         </p:spPr>
         <p:txBody>
-          <a:bodyPr wrap="square" lIns="0" tIns="0" rIns="0" bIns="0">
-            <a:spAutoFit/>
+          <a:bodyPr vertOverflow="overflow" vert="horz" wrap="square" rtlCol="0" anchor="t">
+            <a:noAutofit/>
           </a:bodyPr>
           <a:lstStyle/>
           <a:p>
-            <a:pPr algn="l">
-              <a:spcAft>
-                <a:spcPts val="0"/>
-              </a:spcAft>
-            </a:pPr>
-            <a:r>
-              <a:rPr sz="1200" b="1">
+            <a:pPr algn="l"/>
+            <a:r>
+              <a:rPr lang="en-US" sz="1400" b="1" dirty="0">
                 <a:solidFill>
                   <a:srgbClr val="2563EB"/>
                 </a:solidFill>
-                <a:latin typeface="Segoe UI"/>
-              </a:rPr>
-              <a:t>VL53L8CX DRIVER</a:t>
-            </a:r>
-          </a:p>
-        </p:txBody>
-      </p:sp>
-      <p:sp>
-        <p:nvSpPr>
-          <p:cNvPr id="3" name="TextBox 2"/>
+                <a:latin typeface="Rockwell"/>
+              </a:rPr>
+              <a:t>BUILD-TIME CONFIGURATION</a:t>
+            </a:r>
+          </a:p>
+        </p:txBody>
+      </p:sp>
+      <p:sp>
+        <p:nvSpPr>
+          <p:cNvPr id="3" name="TextBox 2">
+            <a:extLst>
+              <a:ext uri="{FF2B5EF4-FFF2-40B4-BE49-F238E27FC236}">
+                <a16:creationId xmlns:a16="http://schemas.microsoft.com/office/drawing/2014/main" id="{75302636-C4AB-42A0-A355-CFCE2B0D1256}"/>
+              </a:ext>
+            </a:extLst>
+          </p:cNvPr>
           <p:cNvSpPr txBox="1"/>
           <p:nvPr/>
         </p:nvSpPr>
         <p:spPr>
           <a:xfrm>
-            <a:off x="640080" y="621792"/>
-            <a:ext cx="10058400" cy="594360"/>
+            <a:off x="635000" y="609600"/>
+            <a:ext cx="10922000" cy="508000"/>
           </a:xfrm>
           <a:prstGeom prst="rect">
             <a:avLst/>
@@ -9144,51 +9104,51 @@
           <a:noFill/>
         </p:spPr>
         <p:txBody>
-          <a:bodyPr wrap="square" lIns="0" tIns="0" rIns="0" bIns="0">
-            <a:spAutoFit/>
+          <a:bodyPr vertOverflow="overflow" vert="horz" wrap="square" rtlCol="0" anchor="t">
+            <a:noAutofit/>
           </a:bodyPr>
           <a:lstStyle/>
           <a:p>
-            <a:pPr algn="l">
-              <a:spcAft>
-                <a:spcPts val="0"/>
-              </a:spcAft>
-            </a:pPr>
-            <a:r>
-              <a:rPr sz="2700" b="1">
+            <a:pPr algn="l"/>
+            <a:r>
+              <a:rPr lang="en-US" sz="3000" b="1">
                 <a:solidFill>
                   <a:srgbClr val="0F172A"/>
                 </a:solidFill>
-                <a:latin typeface="Segoe UI"/>
-              </a:rPr>
-              <a:t>Status Update: Then vs. Now</a:t>
-            </a:r>
-          </a:p>
-        </p:txBody>
-      </p:sp>
-      <p:sp>
-        <p:nvSpPr>
-          <p:cNvPr id="4" name="Rounded Rectangle 3"/>
+                <a:latin typeface="Rockwell"/>
+              </a:rPr>
+              <a:t>Configuring the kernel with menuconfig</a:t>
+            </a:r>
+          </a:p>
+        </p:txBody>
+      </p:sp>
+      <p:sp>
+        <p:nvSpPr>
+          <p:cNvPr id="4" name="Rectangle: Rounded Corners 3">
+            <a:extLst>
+              <a:ext uri="{FF2B5EF4-FFF2-40B4-BE49-F238E27FC236}">
+                <a16:creationId xmlns:a16="http://schemas.microsoft.com/office/drawing/2014/main" id="{68F4B1B4-763D-4BA6-91D1-4EDB9CD9F4F4}"/>
+              </a:ext>
+            </a:extLst>
+          </p:cNvPr>
           <p:cNvSpPr/>
           <p:nvPr/>
         </p:nvSpPr>
         <p:spPr>
           <a:xfrm>
-            <a:off x="640080" y="1243584"/>
-            <a:ext cx="822960" cy="36576"/>
+            <a:off x="635000" y="1270000"/>
+            <a:ext cx="4191000" cy="431800"/>
           </a:xfrm>
           <a:prstGeom prst="roundRect">
-            <a:avLst>
-              <a:gd name="adj" fmla="val 50000"/>
-            </a:avLst>
+            <a:avLst/>
           </a:prstGeom>
           <a:solidFill>
-            <a:srgbClr val="2563EB"/>
+            <a:srgbClr val="0F172A"/>
           </a:solidFill>
-          <a:ln>
+          <a:ln w="9525" cap="flat" cmpd="sng" algn="ctr">
             <a:noFill/>
+            <a:prstDash val="solid"/>
           </a:ln>
-          <a:effectLst/>
         </p:spPr>
         <p:style>
           <a:lnRef idx="1">
@@ -9205,24 +9165,40 @@
           </a:fontRef>
         </p:style>
         <p:txBody>
-          <a:bodyPr rtlCol="0" anchor="ctr"/>
-          <a:lstStyle/>
-          <a:p>
-            <a:pPr algn="ctr"/>
-            <a:endParaRPr/>
-          </a:p>
-        </p:txBody>
-      </p:sp>
-      <p:sp>
-        <p:nvSpPr>
-          <p:cNvPr id="5" name="TextBox 4"/>
+          <a:bodyPr vertOverflow="clip" horzOverflow="clip" wrap="none" rtlCol="0" anchor="ctr" anchorCtr="0">
+            <a:noAutofit/>
+          </a:bodyPr>
+          <a:lstStyle/>
+          <a:p>
+            <a:pPr algn="l"/>
+            <a:r>
+              <a:rPr lang="en-US" sz="1600" b="1">
+                <a:solidFill>
+                  <a:srgbClr val="93C5FD"/>
+                </a:solidFill>
+                <a:latin typeface="Rockwell"/>
+              </a:rPr>
+              <a:t>west build -t menuconfig</a:t>
+            </a:r>
+          </a:p>
+        </p:txBody>
+      </p:sp>
+      <p:sp>
+        <p:nvSpPr>
+          <p:cNvPr id="5" name="TextBox 4">
+            <a:extLst>
+              <a:ext uri="{FF2B5EF4-FFF2-40B4-BE49-F238E27FC236}">
+                <a16:creationId xmlns:a16="http://schemas.microsoft.com/office/drawing/2014/main" id="{F4F2D0E3-0B1D-4B09-B775-DF4B30AFC7D2}"/>
+              </a:ext>
+            </a:extLst>
+          </p:cNvPr>
           <p:cNvSpPr txBox="1"/>
           <p:nvPr/>
         </p:nvSpPr>
         <p:spPr>
           <a:xfrm>
-            <a:off x="640080" y="6446520"/>
-            <a:ext cx="6400800" cy="274320"/>
+            <a:off x="635000" y="1905000"/>
+            <a:ext cx="4064000" cy="3810000"/>
           </a:xfrm>
           <a:prstGeom prst="rect">
             <a:avLst/>
@@ -9230,459 +9206,121 @@
           <a:noFill/>
         </p:spPr>
         <p:txBody>
-          <a:bodyPr wrap="square" lIns="0" tIns="0" rIns="0" bIns="0">
-            <a:spAutoFit/>
+          <a:bodyPr vertOverflow="overflow" vert="horz" wrap="square" rtlCol="0" anchor="t" anchorCtr="0">
+            <a:noAutofit/>
           </a:bodyPr>
           <a:lstStyle/>
           <a:p>
-            <a:pPr algn="l">
-              <a:spcAft>
-                <a:spcPts val="0"/>
-              </a:spcAft>
-            </a:pPr>
-            <a:r>
-              <a:rPr sz="900" b="0">
-                <a:solidFill>
-                  <a:srgbClr val="64748B"/>
-                </a:solidFill>
-                <a:latin typeface="Segoe UI"/>
-              </a:rPr>
-              <a:t>Zephyr on STM32 → the VL53L8CX Driver</a:t>
-            </a:r>
-          </a:p>
-        </p:txBody>
-      </p:sp>
-      <p:sp>
-        <p:nvSpPr>
-          <p:cNvPr id="7" name="Rounded Rectangle 6"/>
-          <p:cNvSpPr/>
-          <p:nvPr/>
-        </p:nvSpPr>
-        <p:spPr>
-          <a:xfrm>
-            <a:off x="640080" y="1508760"/>
-            <a:ext cx="5333999" cy="4709160"/>
-          </a:xfrm>
-          <a:prstGeom prst="roundRect">
-            <a:avLst>
-              <a:gd name="adj" fmla="val 4000"/>
-            </a:avLst>
-          </a:prstGeom>
-          <a:solidFill>
-            <a:srgbClr val="0F172A"/>
-          </a:solidFill>
-          <a:ln>
-            <a:noFill/>
-          </a:ln>
-          <a:effectLst/>
-        </p:spPr>
-        <p:style>
-          <a:lnRef idx="1">
-            <a:schemeClr val="accent1"/>
-          </a:lnRef>
-          <a:fillRef idx="3">
-            <a:schemeClr val="accent1"/>
-          </a:fillRef>
-          <a:effectRef idx="2">
-            <a:schemeClr val="accent1"/>
-          </a:effectRef>
-          <a:fontRef idx="minor">
-            <a:schemeClr val="lt1"/>
-          </a:fontRef>
-        </p:style>
-        <p:txBody>
-          <a:bodyPr rtlCol="0" anchor="ctr"/>
-          <a:lstStyle/>
-          <a:p>
-            <a:pPr algn="ctr"/>
-            <a:endParaRPr/>
-          </a:p>
-        </p:txBody>
-      </p:sp>
-      <p:sp>
-        <p:nvSpPr>
-          <p:cNvPr id="8" name="TextBox 7"/>
-          <p:cNvSpPr txBox="1"/>
-          <p:nvPr/>
-        </p:nvSpPr>
-        <p:spPr>
-          <a:xfrm>
-            <a:off x="868680" y="1691640"/>
-            <a:ext cx="4876799" cy="320040"/>
-          </a:xfrm>
-          <a:prstGeom prst="rect">
-            <a:avLst/>
-          </a:prstGeom>
-          <a:noFill/>
-        </p:spPr>
-        <p:txBody>
-          <a:bodyPr wrap="square" lIns="0" tIns="0" rIns="0" bIns="0">
-            <a:spAutoFit/>
-          </a:bodyPr>
-          <a:lstStyle/>
-          <a:p>
-            <a:pPr algn="l">
-              <a:spcAft>
-                <a:spcPts val="0"/>
-              </a:spcAft>
-            </a:pPr>
-            <a:r>
-              <a:rPr sz="1200" b="1">
-                <a:solidFill>
-                  <a:srgbClr val="10B981"/>
-                </a:solidFill>
-                <a:latin typeface="Segoe UI"/>
-              </a:rPr>
-              <a:t>FIXED SINCE THE LAST REVIEW</a:t>
-            </a:r>
-          </a:p>
-        </p:txBody>
-      </p:sp>
-      <p:sp>
-        <p:nvSpPr>
-          <p:cNvPr id="9" name="Oval 8"/>
-          <p:cNvSpPr/>
-          <p:nvPr/>
-        </p:nvSpPr>
-        <p:spPr>
-          <a:xfrm>
-            <a:off x="868680" y="2103120"/>
-            <a:ext cx="320040" cy="320040"/>
-          </a:xfrm>
-          <a:prstGeom prst="ellipse">
-            <a:avLst/>
-          </a:prstGeom>
-          <a:solidFill>
-            <a:srgbClr val="10B981"/>
-          </a:solidFill>
-          <a:ln>
-            <a:noFill/>
-          </a:ln>
-          <a:effectLst/>
-        </p:spPr>
-        <p:style>
-          <a:lnRef idx="1">
-            <a:schemeClr val="accent1"/>
-          </a:lnRef>
-          <a:fillRef idx="3">
-            <a:schemeClr val="accent1"/>
-          </a:fillRef>
-          <a:effectRef idx="2">
-            <a:schemeClr val="accent1"/>
-          </a:effectRef>
-          <a:fontRef idx="minor">
-            <a:schemeClr val="lt1"/>
-          </a:fontRef>
-        </p:style>
-        <p:txBody>
-          <a:bodyPr rtlCol="0" anchor="ctr"/>
-          <a:lstStyle/>
-          <a:p>
-            <a:pPr algn="ctr"/>
-            <a:endParaRPr/>
-          </a:p>
-        </p:txBody>
-      </p:sp>
-      <p:sp>
-        <p:nvSpPr>
-          <p:cNvPr id="10" name="TextBox 9"/>
-          <p:cNvSpPr txBox="1"/>
-          <p:nvPr/>
-        </p:nvSpPr>
-        <p:spPr>
-          <a:xfrm>
-            <a:off x="868680" y="2103120"/>
-            <a:ext cx="320040" cy="320040"/>
-          </a:xfrm>
-          <a:prstGeom prst="rect">
-            <a:avLst/>
-          </a:prstGeom>
-          <a:noFill/>
-        </p:spPr>
-        <p:txBody>
-          <a:bodyPr wrap="square" lIns="0" tIns="0" rIns="0" bIns="0" anchor="ctr">
-            <a:spAutoFit/>
-          </a:bodyPr>
-          <a:lstStyle/>
-          <a:p>
-            <a:pPr algn="ctr">
-              <a:spcAft>
-                <a:spcPts val="0"/>
-              </a:spcAft>
-            </a:pPr>
-            <a:r>
-              <a:rPr sz="1100" b="1">
-                <a:solidFill>
-                  <a:srgbClr val="FFFFFF"/>
-                </a:solidFill>
-                <a:latin typeface="Segoe UI"/>
-              </a:rPr>
-              <a:t>✓</a:t>
-            </a:r>
-          </a:p>
-        </p:txBody>
-      </p:sp>
-      <p:sp>
-        <p:nvSpPr>
-          <p:cNvPr id="11" name="TextBox 10"/>
-          <p:cNvSpPr txBox="1"/>
-          <p:nvPr/>
-        </p:nvSpPr>
-        <p:spPr>
-          <a:xfrm>
-            <a:off x="1280160" y="2075688"/>
-            <a:ext cx="4465319" cy="930656"/>
-          </a:xfrm>
-          <a:prstGeom prst="rect">
-            <a:avLst/>
-          </a:prstGeom>
-          <a:noFill/>
-        </p:spPr>
-        <p:txBody>
-          <a:bodyPr wrap="square" lIns="0" tIns="0" rIns="0" bIns="0">
-            <a:spAutoFit/>
-          </a:bodyPr>
-          <a:lstStyle/>
-          <a:p>
-            <a:pPr algn="l">
+            <a:pPr marL="228600" indent="-228600">
               <a:lnSpc>
                 <a:spcPct val="115000"/>
               </a:lnSpc>
               <a:spcAft>
-                <a:spcPts val="200"/>
-              </a:spcAft>
-            </a:pPr>
-            <a:r>
-              <a:rPr sz="1100" b="1">
-                <a:solidFill>
-                  <a:srgbClr val="FFFFFF"/>
-                </a:solidFill>
-                <a:latin typeface="Segoe UI"/>
-              </a:rPr>
-              <a:t>module.yml, Kconfig, CMakeLists.txt</a:t>
-            </a:r>
-          </a:p>
-          <a:p>
-            <a:pPr algn="l">
+                <a:spcPts val="900"/>
+              </a:spcAft>
+              <a:buFont typeface="Arial"/>
+              <a:buChar char="•"/>
+            </a:pPr>
+            <a:r>
+              <a:rPr lang="en-US" sz="1600" dirty="0">
+                <a:solidFill>
+                  <a:srgbClr val="0F172A"/>
+                </a:solidFill>
+                <a:latin typeface="Rockwell" panose="02060603020205020403" pitchFamily="18" charset="0"/>
+              </a:rPr>
+              <a:t>Opens the Kconfig menu for the whole build — kernel, subsystems, drivers and every module in the workspace.</a:t>
+            </a:r>
+          </a:p>
+          <a:p>
+            <a:pPr marL="228600" indent="-228600">
               <a:lnSpc>
                 <a:spcPct val="115000"/>
               </a:lnSpc>
               <a:spcAft>
-                <a:spcPts val="200"/>
-              </a:spcAft>
-            </a:pPr>
-            <a:r>
-              <a:rPr sz="950" b="0">
-                <a:solidFill>
-                  <a:srgbClr val="CBD5E1"/>
-                </a:solidFill>
-                <a:latin typeface="Segoe UI"/>
-              </a:rPr>
-              <a:t>Fully populated, no longer empty stubs.</a:t>
-            </a:r>
-          </a:p>
-        </p:txBody>
-      </p:sp>
-      <p:sp>
-        <p:nvSpPr>
-          <p:cNvPr id="12" name="Oval 11"/>
-          <p:cNvSpPr/>
-          <p:nvPr/>
-        </p:nvSpPr>
-        <p:spPr>
-          <a:xfrm>
-            <a:off x="868680" y="3088640"/>
-            <a:ext cx="320040" cy="320040"/>
-          </a:xfrm>
-          <a:prstGeom prst="ellipse">
-            <a:avLst/>
-          </a:prstGeom>
-          <a:solidFill>
-            <a:srgbClr val="10B981"/>
-          </a:solidFill>
-          <a:ln>
-            <a:noFill/>
-          </a:ln>
-          <a:effectLst/>
-        </p:spPr>
-        <p:style>
-          <a:lnRef idx="1">
-            <a:schemeClr val="accent1"/>
-          </a:lnRef>
-          <a:fillRef idx="3">
-            <a:schemeClr val="accent1"/>
-          </a:fillRef>
-          <a:effectRef idx="2">
-            <a:schemeClr val="accent1"/>
-          </a:effectRef>
-          <a:fontRef idx="minor">
-            <a:schemeClr val="lt1"/>
-          </a:fontRef>
-        </p:style>
-        <p:txBody>
-          <a:bodyPr rtlCol="0" anchor="ctr"/>
-          <a:lstStyle/>
-          <a:p>
-            <a:pPr algn="ctr"/>
-            <a:endParaRPr/>
-          </a:p>
-        </p:txBody>
-      </p:sp>
-      <p:sp>
-        <p:nvSpPr>
-          <p:cNvPr id="13" name="TextBox 12"/>
-          <p:cNvSpPr txBox="1"/>
-          <p:nvPr/>
-        </p:nvSpPr>
-        <p:spPr>
-          <a:xfrm>
-            <a:off x="868680" y="3088640"/>
-            <a:ext cx="320040" cy="320040"/>
-          </a:xfrm>
-          <a:prstGeom prst="rect">
-            <a:avLst/>
-          </a:prstGeom>
-          <a:noFill/>
-        </p:spPr>
-        <p:txBody>
-          <a:bodyPr wrap="square" lIns="0" tIns="0" rIns="0" bIns="0" anchor="ctr">
-            <a:spAutoFit/>
-          </a:bodyPr>
-          <a:lstStyle/>
-          <a:p>
-            <a:pPr algn="ctr">
-              <a:spcAft>
-                <a:spcPts val="0"/>
-              </a:spcAft>
-            </a:pPr>
-            <a:r>
-              <a:rPr sz="1100" b="1">
-                <a:solidFill>
-                  <a:srgbClr val="FFFFFF"/>
-                </a:solidFill>
-                <a:latin typeface="Segoe UI"/>
-              </a:rPr>
-              <a:t>✓</a:t>
-            </a:r>
-          </a:p>
-        </p:txBody>
-      </p:sp>
-      <p:sp>
-        <p:nvSpPr>
-          <p:cNvPr id="14" name="TextBox 13"/>
-          <p:cNvSpPr txBox="1"/>
-          <p:nvPr/>
-        </p:nvSpPr>
-        <p:spPr>
-          <a:xfrm>
-            <a:off x="1280160" y="3061208"/>
-            <a:ext cx="4465319" cy="930656"/>
-          </a:xfrm>
-          <a:prstGeom prst="rect">
-            <a:avLst/>
-          </a:prstGeom>
-          <a:noFill/>
-        </p:spPr>
-        <p:txBody>
-          <a:bodyPr wrap="square" lIns="0" tIns="0" rIns="0" bIns="0">
-            <a:spAutoFit/>
-          </a:bodyPr>
-          <a:lstStyle/>
-          <a:p>
-            <a:pPr algn="l">
+                <a:spcPts val="900"/>
+              </a:spcAft>
+              <a:buFont typeface="Arial"/>
+              <a:buChar char="•"/>
+            </a:pPr>
+            <a:r>
+              <a:rPr lang="en-US" sz="1600" dirty="0">
+                <a:solidFill>
+                  <a:srgbClr val="0F172A"/>
+                </a:solidFill>
+                <a:latin typeface="Rockwell" panose="02060603020205020403" pitchFamily="18" charset="0"/>
+              </a:rPr>
+              <a:t>Toggle features directly: CONFIG_I2C, CONFIG_SENSOR, log levels, MPU, power management.</a:t>
+            </a:r>
+          </a:p>
+          <a:p>
+            <a:pPr marL="228600" indent="-228600">
               <a:lnSpc>
                 <a:spcPct val="115000"/>
               </a:lnSpc>
               <a:spcAft>
-                <a:spcPts val="200"/>
-              </a:spcAft>
-            </a:pPr>
-            <a:r>
-              <a:rPr sz="1100" b="1">
-                <a:solidFill>
-                  <a:srgbClr val="FFFFFF"/>
-                </a:solidFill>
-                <a:latin typeface="Segoe UI"/>
-              </a:rPr>
-              <a:t>Devicetree binding written</a:t>
-            </a:r>
-          </a:p>
-          <a:p>
-            <a:pPr algn="l">
+                <a:spcPts val="900"/>
+              </a:spcAft>
+              <a:buFont typeface="Arial"/>
+              <a:buChar char="•"/>
+            </a:pPr>
+            <a:r>
+              <a:rPr lang="en-US" sz="1600" dirty="0">
+                <a:solidFill>
+                  <a:srgbClr val="0F172A"/>
+                </a:solidFill>
+                <a:latin typeface="Rockwell" panose="02060603020205020403" pitchFamily="18" charset="0"/>
+              </a:rPr>
+              <a:t>Choices land in build/zephyr/.config — promote them to prj.conf to make them permanent.</a:t>
+            </a:r>
+          </a:p>
+          <a:p>
+            <a:pPr marL="228600" indent="-228600">
               <a:lnSpc>
                 <a:spcPct val="115000"/>
               </a:lnSpc>
               <a:spcAft>
-                <a:spcPts val="200"/>
-              </a:spcAft>
-            </a:pPr>
-            <a:r>
-              <a:rPr sz="950" b="0">
-                <a:solidFill>
-                  <a:srgbClr val="CBD5E1"/>
-                </a:solidFill>
-                <a:latin typeface="Segoe UI"/>
-              </a:rPr>
-              <a:t>dts/bindings/sensor/st,vl53l8cx.yaml now exists.</a:t>
-            </a:r>
-          </a:p>
-        </p:txBody>
-      </p:sp>
-      <p:sp>
-        <p:nvSpPr>
-          <p:cNvPr id="15" name="Oval 14"/>
-          <p:cNvSpPr/>
-          <p:nvPr/>
-        </p:nvSpPr>
-        <p:spPr>
-          <a:xfrm>
-            <a:off x="868680" y="4074160"/>
-            <a:ext cx="320040" cy="320040"/>
-          </a:xfrm>
-          <a:prstGeom prst="ellipse">
-            <a:avLst/>
-          </a:prstGeom>
-          <a:solidFill>
-            <a:srgbClr val="10B981"/>
-          </a:solidFill>
-          <a:ln>
-            <a:noFill/>
-          </a:ln>
-          <a:effectLst/>
-        </p:spPr>
-        <p:style>
-          <a:lnRef idx="1">
-            <a:schemeClr val="accent1"/>
-          </a:lnRef>
-          <a:fillRef idx="3">
-            <a:schemeClr val="accent1"/>
-          </a:fillRef>
-          <a:effectRef idx="2">
-            <a:schemeClr val="accent1"/>
-          </a:effectRef>
-          <a:fontRef idx="minor">
-            <a:schemeClr val="lt1"/>
-          </a:fontRef>
-        </p:style>
-        <p:txBody>
-          <a:bodyPr rtlCol="0" anchor="ctr"/>
-          <a:lstStyle/>
-          <a:p>
-            <a:pPr algn="ctr"/>
-            <a:endParaRPr/>
-          </a:p>
-        </p:txBody>
-      </p:sp>
-      <p:sp>
-        <p:nvSpPr>
-          <p:cNvPr id="16" name="TextBox 15"/>
+                <a:spcPts val="0"/>
+              </a:spcAft>
+              <a:buFont typeface="Arial"/>
+              <a:buChar char="•"/>
+            </a:pPr>
+            <a:r>
+              <a:rPr lang="en-US" sz="1600" b="1" dirty="0">
+                <a:solidFill>
+                  <a:srgbClr val="B45309"/>
+                </a:solidFill>
+                <a:latin typeface="Rockwell" panose="02060603020205020403" pitchFamily="18" charset="0"/>
+              </a:rPr>
+              <a:t>Still not fully mature: </a:t>
+            </a:r>
+            <a:r>
+              <a:rPr lang="en-US" sz="1600" dirty="0">
+                <a:solidFill>
+                  <a:srgbClr val="B45309"/>
+                </a:solidFill>
+                <a:latin typeface="Rockwell" panose="02060603020205020403" pitchFamily="18" charset="0"/>
+              </a:rPr>
+              <a:t>terminal-only UI, limited search, and a pristine rebuild discards anything not in prj.conf.</a:t>
+            </a:r>
+          </a:p>
+        </p:txBody>
+      </p:sp>
+      <p:sp>
+        <p:nvSpPr>
+          <p:cNvPr id="6" name="TextBox 5">
+            <a:extLst>
+              <a:ext uri="{FF2B5EF4-FFF2-40B4-BE49-F238E27FC236}">
+                <a16:creationId xmlns:a16="http://schemas.microsoft.com/office/drawing/2014/main" id="{9928E159-A53B-476D-BE54-E8889237F3EA}"/>
+              </a:ext>
+            </a:extLst>
+          </p:cNvPr>
           <p:cNvSpPr txBox="1"/>
           <p:nvPr/>
         </p:nvSpPr>
         <p:spPr>
           <a:xfrm>
-            <a:off x="868680" y="4074160"/>
-            <a:ext cx="320040" cy="320040"/>
+            <a:off x="4953000" y="5384800"/>
+            <a:ext cx="6604000" cy="254000"/>
           </a:xfrm>
           <a:prstGeom prst="rect">
             <a:avLst/>
@@ -9690,611 +9328,60 @@
           <a:noFill/>
         </p:spPr>
         <p:txBody>
-          <a:bodyPr wrap="square" lIns="0" tIns="0" rIns="0" bIns="0" anchor="ctr">
-            <a:spAutoFit/>
+          <a:bodyPr vertOverflow="overflow" vert="horz" wrap="square" rtlCol="0" anchor="t">
+            <a:noAutofit/>
           </a:bodyPr>
           <a:lstStyle/>
           <a:p>
-            <a:pPr algn="ctr">
-              <a:spcAft>
-                <a:spcPts val="0"/>
-              </a:spcAft>
-            </a:pPr>
-            <a:r>
-              <a:rPr sz="1100" b="1">
-                <a:solidFill>
-                  <a:srgbClr val="FFFFFF"/>
-                </a:solidFill>
-                <a:latin typeface="Segoe UI"/>
-              </a:rPr>
-              <a:t>✓</a:t>
-            </a:r>
-          </a:p>
-        </p:txBody>
-      </p:sp>
-      <p:sp>
-        <p:nvSpPr>
-          <p:cNvPr id="17" name="TextBox 16"/>
-          <p:cNvSpPr txBox="1"/>
-          <p:nvPr/>
-        </p:nvSpPr>
-        <p:spPr>
-          <a:xfrm>
-            <a:off x="1280160" y="4046728"/>
-            <a:ext cx="4465319" cy="930656"/>
-          </a:xfrm>
-          <a:prstGeom prst="rect">
-            <a:avLst/>
-          </a:prstGeom>
-          <a:noFill/>
-        </p:spPr>
-        <p:txBody>
-          <a:bodyPr wrap="square" lIns="0" tIns="0" rIns="0" bIns="0">
-            <a:spAutoFit/>
-          </a:bodyPr>
-          <a:lstStyle/>
-          <a:p>
-            <a:pPr algn="l">
-              <a:lnSpc>
-                <a:spcPct val="115000"/>
-              </a:lnSpc>
-              <a:spcAft>
-                <a:spcPts val="200"/>
-              </a:spcAft>
-            </a:pPr>
-            <a:r>
-              <a:rPr sz="1100" b="1">
-                <a:solidFill>
-                  <a:srgbClr val="FFFFFF"/>
-                </a:solidFill>
-                <a:latin typeface="Segoe UI"/>
-              </a:rPr>
-              <a:t>Sample app builds on 2 boards</a:t>
-            </a:r>
-          </a:p>
-          <a:p>
-            <a:pPr algn="l">
-              <a:lnSpc>
-                <a:spcPct val="115000"/>
-              </a:lnSpc>
-              <a:spcAft>
-                <a:spcPts val="200"/>
-              </a:spcAft>
-            </a:pPr>
-            <a:r>
-              <a:rPr sz="950" b="0">
-                <a:solidFill>
-                  <a:srgbClr val="CBD5E1"/>
-                </a:solidFill>
-                <a:latin typeface="Segoe UI"/>
-              </a:rPr>
-              <a:t>vl53l8cx_simple, overlays for G474RE &amp; N657X0-Q.</a:t>
-            </a:r>
-          </a:p>
-        </p:txBody>
-      </p:sp>
-      <p:sp>
-        <p:nvSpPr>
-          <p:cNvPr id="18" name="Oval 17"/>
-          <p:cNvSpPr/>
-          <p:nvPr/>
-        </p:nvSpPr>
-        <p:spPr>
-          <a:xfrm>
-            <a:off x="868680" y="5059680"/>
-            <a:ext cx="320040" cy="320040"/>
-          </a:xfrm>
-          <a:prstGeom prst="ellipse">
-            <a:avLst/>
-          </a:prstGeom>
-          <a:solidFill>
-            <a:srgbClr val="10B981"/>
-          </a:solidFill>
-          <a:ln>
-            <a:noFill/>
-          </a:ln>
-          <a:effectLst/>
-        </p:spPr>
-        <p:style>
-          <a:lnRef idx="1">
-            <a:schemeClr val="accent1"/>
-          </a:lnRef>
-          <a:fillRef idx="3">
-            <a:schemeClr val="accent1"/>
-          </a:fillRef>
-          <a:effectRef idx="2">
-            <a:schemeClr val="accent1"/>
-          </a:effectRef>
-          <a:fontRef idx="minor">
-            <a:schemeClr val="lt1"/>
-          </a:fontRef>
-        </p:style>
-        <p:txBody>
-          <a:bodyPr rtlCol="0" anchor="ctr"/>
-          <a:lstStyle/>
-          <a:p>
-            <a:pPr algn="ctr"/>
-            <a:endParaRPr/>
-          </a:p>
-        </p:txBody>
-      </p:sp>
-      <p:sp>
-        <p:nvSpPr>
-          <p:cNvPr id="19" name="TextBox 18"/>
-          <p:cNvSpPr txBox="1"/>
-          <p:nvPr/>
-        </p:nvSpPr>
-        <p:spPr>
-          <a:xfrm>
-            <a:off x="868680" y="5059680"/>
-            <a:ext cx="320040" cy="320040"/>
-          </a:xfrm>
-          <a:prstGeom prst="rect">
-            <a:avLst/>
-          </a:prstGeom>
-          <a:noFill/>
-        </p:spPr>
-        <p:txBody>
-          <a:bodyPr wrap="square" lIns="0" tIns="0" rIns="0" bIns="0" anchor="ctr">
-            <a:spAutoFit/>
-          </a:bodyPr>
-          <a:lstStyle/>
-          <a:p>
-            <a:pPr algn="ctr">
-              <a:spcAft>
-                <a:spcPts val="0"/>
-              </a:spcAft>
-            </a:pPr>
-            <a:r>
-              <a:rPr sz="1100" b="1">
-                <a:solidFill>
-                  <a:srgbClr val="FFFFFF"/>
-                </a:solidFill>
-                <a:latin typeface="Segoe UI"/>
-              </a:rPr>
-              <a:t>✓</a:t>
-            </a:r>
-          </a:p>
-        </p:txBody>
-      </p:sp>
-      <p:sp>
-        <p:nvSpPr>
-          <p:cNvPr id="20" name="TextBox 19"/>
-          <p:cNvSpPr txBox="1"/>
-          <p:nvPr/>
-        </p:nvSpPr>
-        <p:spPr>
-          <a:xfrm>
-            <a:off x="1280160" y="5032248"/>
-            <a:ext cx="4465319" cy="930656"/>
-          </a:xfrm>
-          <a:prstGeom prst="rect">
-            <a:avLst/>
-          </a:prstGeom>
-          <a:noFill/>
-        </p:spPr>
-        <p:txBody>
-          <a:bodyPr wrap="square" lIns="0" tIns="0" rIns="0" bIns="0">
-            <a:spAutoFit/>
-          </a:bodyPr>
-          <a:lstStyle/>
-          <a:p>
-            <a:pPr algn="l">
-              <a:lnSpc>
-                <a:spcPct val="115000"/>
-              </a:lnSpc>
-              <a:spcAft>
-                <a:spcPts val="200"/>
-              </a:spcAft>
-            </a:pPr>
-            <a:r>
-              <a:rPr sz="1100" b="1">
-                <a:solidFill>
-                  <a:srgbClr val="FFFFFF"/>
-                </a:solidFill>
-                <a:latin typeface="Segoe UI"/>
-              </a:rPr>
-              <a:t>Real version control</a:t>
-            </a:r>
-          </a:p>
-          <a:p>
-            <a:pPr algn="l">
-              <a:lnSpc>
-                <a:spcPct val="115000"/>
-              </a:lnSpc>
-              <a:spcAft>
-                <a:spcPts val="200"/>
-              </a:spcAft>
-            </a:pPr>
-            <a:r>
-              <a:rPr sz="950" b="0">
-                <a:solidFill>
-                  <a:srgbClr val="CBD5E1"/>
-                </a:solidFill>
-                <a:latin typeface="Segoe UI"/>
-              </a:rPr>
-              <a:t>Proper git repo, 2 commits, ~2,460 lines of code.</a:t>
-            </a:r>
-          </a:p>
-        </p:txBody>
-      </p:sp>
-      <p:sp>
-        <p:nvSpPr>
-          <p:cNvPr id="21" name="Rounded Rectangle 20"/>
-          <p:cNvSpPr/>
-          <p:nvPr/>
-        </p:nvSpPr>
-        <p:spPr>
-          <a:xfrm>
-            <a:off x="6135120" y="1508760"/>
-            <a:ext cx="5333999" cy="4709160"/>
-          </a:xfrm>
-          <a:prstGeom prst="roundRect">
-            <a:avLst>
-              <a:gd name="adj" fmla="val 4000"/>
-            </a:avLst>
-          </a:prstGeom>
-          <a:solidFill>
-            <a:srgbClr val="0F172A"/>
-          </a:solidFill>
-          <a:ln>
-            <a:noFill/>
-          </a:ln>
-          <a:effectLst/>
-        </p:spPr>
-        <p:style>
-          <a:lnRef idx="1">
-            <a:schemeClr val="accent1"/>
-          </a:lnRef>
-          <a:fillRef idx="3">
-            <a:schemeClr val="accent1"/>
-          </a:fillRef>
-          <a:effectRef idx="2">
-            <a:schemeClr val="accent1"/>
-          </a:effectRef>
-          <a:fontRef idx="minor">
-            <a:schemeClr val="lt1"/>
-          </a:fontRef>
-        </p:style>
-        <p:txBody>
-          <a:bodyPr rtlCol="0" anchor="ctr"/>
-          <a:lstStyle/>
-          <a:p>
-            <a:pPr algn="ctr"/>
-            <a:endParaRPr/>
-          </a:p>
-        </p:txBody>
-      </p:sp>
-      <p:sp>
-        <p:nvSpPr>
-          <p:cNvPr id="22" name="TextBox 21"/>
-          <p:cNvSpPr txBox="1"/>
-          <p:nvPr/>
-        </p:nvSpPr>
-        <p:spPr>
-          <a:xfrm>
-            <a:off x="6363720" y="1691640"/>
-            <a:ext cx="4876799" cy="320040"/>
-          </a:xfrm>
-          <a:prstGeom prst="rect">
-            <a:avLst/>
-          </a:prstGeom>
-          <a:noFill/>
-        </p:spPr>
-        <p:txBody>
-          <a:bodyPr wrap="square" lIns="0" tIns="0" rIns="0" bIns="0">
-            <a:spAutoFit/>
-          </a:bodyPr>
-          <a:lstStyle/>
-          <a:p>
-            <a:pPr algn="l">
-              <a:spcAft>
-                <a:spcPts val="0"/>
-              </a:spcAft>
-            </a:pPr>
-            <a:r>
-              <a:rPr sz="1200" b="1">
-                <a:solidFill>
-                  <a:srgbClr val="EF4444"/>
-                </a:solidFill>
-                <a:latin typeface="Segoe UI"/>
-              </a:rPr>
-              <a:t>STILL OPEN</a:t>
-            </a:r>
-          </a:p>
-        </p:txBody>
-      </p:sp>
-      <p:sp>
-        <p:nvSpPr>
-          <p:cNvPr id="23" name="Oval 22"/>
-          <p:cNvSpPr/>
-          <p:nvPr/>
-        </p:nvSpPr>
-        <p:spPr>
-          <a:xfrm>
-            <a:off x="6363720" y="2103120"/>
-            <a:ext cx="320040" cy="320040"/>
-          </a:xfrm>
-          <a:prstGeom prst="ellipse">
-            <a:avLst/>
-          </a:prstGeom>
-          <a:solidFill>
-            <a:srgbClr val="EF4444"/>
-          </a:solidFill>
-          <a:ln>
-            <a:noFill/>
-          </a:ln>
-          <a:effectLst/>
-        </p:spPr>
-        <p:style>
-          <a:lnRef idx="1">
-            <a:schemeClr val="accent1"/>
-          </a:lnRef>
-          <a:fillRef idx="3">
-            <a:schemeClr val="accent1"/>
-          </a:fillRef>
-          <a:effectRef idx="2">
-            <a:schemeClr val="accent1"/>
-          </a:effectRef>
-          <a:fontRef idx="minor">
-            <a:schemeClr val="lt1"/>
-          </a:fontRef>
-        </p:style>
-        <p:txBody>
-          <a:bodyPr rtlCol="0" anchor="ctr"/>
-          <a:lstStyle/>
-          <a:p>
-            <a:pPr algn="ctr"/>
-            <a:endParaRPr/>
-          </a:p>
-        </p:txBody>
-      </p:sp>
-      <p:sp>
-        <p:nvSpPr>
-          <p:cNvPr id="24" name="TextBox 23"/>
-          <p:cNvSpPr txBox="1"/>
-          <p:nvPr/>
-        </p:nvSpPr>
-        <p:spPr>
-          <a:xfrm>
-            <a:off x="6363720" y="2103120"/>
-            <a:ext cx="320040" cy="320040"/>
-          </a:xfrm>
-          <a:prstGeom prst="rect">
-            <a:avLst/>
-          </a:prstGeom>
-          <a:noFill/>
-        </p:spPr>
-        <p:txBody>
-          <a:bodyPr wrap="square" lIns="0" tIns="0" rIns="0" bIns="0" anchor="ctr">
-            <a:spAutoFit/>
-          </a:bodyPr>
-          <a:lstStyle/>
-          <a:p>
-            <a:pPr algn="ctr">
-              <a:spcAft>
-                <a:spcPts val="0"/>
-              </a:spcAft>
-            </a:pPr>
-            <a:r>
-              <a:rPr sz="1100" b="1">
-                <a:solidFill>
-                  <a:srgbClr val="FFFFFF"/>
-                </a:solidFill>
-                <a:latin typeface="Segoe UI"/>
-              </a:rPr>
-              <a:t>✗</a:t>
-            </a:r>
-          </a:p>
-        </p:txBody>
-      </p:sp>
-      <p:sp>
-        <p:nvSpPr>
-          <p:cNvPr id="25" name="TextBox 24"/>
-          <p:cNvSpPr txBox="1"/>
-          <p:nvPr/>
-        </p:nvSpPr>
-        <p:spPr>
-          <a:xfrm>
-            <a:off x="6775200" y="2075688"/>
-            <a:ext cx="4465319" cy="930656"/>
-          </a:xfrm>
-          <a:prstGeom prst="rect">
-            <a:avLst/>
-          </a:prstGeom>
-          <a:noFill/>
-        </p:spPr>
-        <p:txBody>
-          <a:bodyPr wrap="square" lIns="0" tIns="0" rIns="0" bIns="0">
-            <a:spAutoFit/>
-          </a:bodyPr>
-          <a:lstStyle/>
-          <a:p>
-            <a:pPr algn="l">
-              <a:lnSpc>
-                <a:spcPct val="115000"/>
-              </a:lnSpc>
-              <a:spcAft>
-                <a:spcPts val="200"/>
-              </a:spcAft>
-            </a:pPr>
-            <a:r>
-              <a:rPr sz="1100" b="1">
-                <a:solidFill>
-                  <a:srgbClr val="FFFFFF"/>
-                </a:solidFill>
-                <a:latin typeface="Segoe UI"/>
-              </a:rPr>
-              <a:t>Polluted vendor source</a:t>
-            </a:r>
-          </a:p>
-          <a:p>
-            <a:pPr algn="l">
-              <a:lnSpc>
-                <a:spcPct val="115000"/>
-              </a:lnSpc>
-              <a:spcAft>
-                <a:spcPts val="200"/>
-              </a:spcAft>
-            </a:pPr>
-            <a:r>
-              <a:rPr sz="950" b="0">
-                <a:solidFill>
-                  <a:srgbClr val="CBD5E1"/>
-                </a:solidFill>
-                <a:latin typeface="Segoe UI"/>
-              </a:rPr>
-              <a:t>uld/vl53l8cx_api.c still has a #include and 6 printk() debug calls hand-spliced in.</a:t>
-            </a:r>
-          </a:p>
-        </p:txBody>
-      </p:sp>
-      <p:sp>
-        <p:nvSpPr>
-          <p:cNvPr id="26" name="Oval 25"/>
-          <p:cNvSpPr/>
-          <p:nvPr/>
-        </p:nvSpPr>
-        <p:spPr>
-          <a:xfrm>
-            <a:off x="6363720" y="3088640"/>
-            <a:ext cx="320040" cy="320040"/>
-          </a:xfrm>
-          <a:prstGeom prst="ellipse">
-            <a:avLst/>
-          </a:prstGeom>
-          <a:solidFill>
-            <a:srgbClr val="EF4444"/>
-          </a:solidFill>
-          <a:ln>
-            <a:noFill/>
-          </a:ln>
-          <a:effectLst/>
-        </p:spPr>
-        <p:style>
-          <a:lnRef idx="1">
-            <a:schemeClr val="accent1"/>
-          </a:lnRef>
-          <a:fillRef idx="3">
-            <a:schemeClr val="accent1"/>
-          </a:fillRef>
-          <a:effectRef idx="2">
-            <a:schemeClr val="accent1"/>
-          </a:effectRef>
-          <a:fontRef idx="minor">
-            <a:schemeClr val="lt1"/>
-          </a:fontRef>
-        </p:style>
-        <p:txBody>
-          <a:bodyPr rtlCol="0" anchor="ctr"/>
-          <a:lstStyle/>
-          <a:p>
-            <a:pPr algn="ctr"/>
-            <a:endParaRPr/>
-          </a:p>
-        </p:txBody>
-      </p:sp>
-      <p:sp>
-        <p:nvSpPr>
-          <p:cNvPr id="27" name="TextBox 26"/>
-          <p:cNvSpPr txBox="1"/>
-          <p:nvPr/>
-        </p:nvSpPr>
-        <p:spPr>
-          <a:xfrm>
-            <a:off x="6363720" y="3088640"/>
-            <a:ext cx="320040" cy="320040"/>
-          </a:xfrm>
-          <a:prstGeom prst="rect">
-            <a:avLst/>
-          </a:prstGeom>
-          <a:noFill/>
-        </p:spPr>
-        <p:txBody>
-          <a:bodyPr wrap="square" lIns="0" tIns="0" rIns="0" bIns="0" anchor="ctr">
-            <a:spAutoFit/>
-          </a:bodyPr>
-          <a:lstStyle/>
-          <a:p>
-            <a:pPr algn="ctr">
-              <a:spcAft>
-                <a:spcPts val="0"/>
-              </a:spcAft>
-            </a:pPr>
-            <a:r>
-              <a:rPr sz="1100" b="1">
-                <a:solidFill>
-                  <a:srgbClr val="FFFFFF"/>
-                </a:solidFill>
-                <a:latin typeface="Segoe UI"/>
-              </a:rPr>
-              <a:t>✗</a:t>
-            </a:r>
-          </a:p>
-        </p:txBody>
-      </p:sp>
-      <p:sp>
-        <p:nvSpPr>
-          <p:cNvPr id="28" name="TextBox 27"/>
-          <p:cNvSpPr txBox="1"/>
-          <p:nvPr/>
-        </p:nvSpPr>
-        <p:spPr>
-          <a:xfrm>
-            <a:off x="6775200" y="3061208"/>
-            <a:ext cx="4465319" cy="930656"/>
-          </a:xfrm>
-          <a:prstGeom prst="rect">
-            <a:avLst/>
-          </a:prstGeom>
-          <a:noFill/>
-        </p:spPr>
-        <p:txBody>
-          <a:bodyPr wrap="square" lIns="0" tIns="0" rIns="0" bIns="0">
-            <a:spAutoFit/>
-          </a:bodyPr>
-          <a:lstStyle/>
-          <a:p>
-            <a:pPr algn="l">
-              <a:lnSpc>
-                <a:spcPct val="115000"/>
-              </a:lnSpc>
-              <a:spcAft>
-                <a:spcPts val="200"/>
-              </a:spcAft>
-            </a:pPr>
-            <a:r>
-              <a:rPr sz="1100" b="1">
-                <a:solidFill>
-                  <a:srgbClr val="FFFFFF"/>
-                </a:solidFill>
-                <a:latin typeface="Segoe UI"/>
-              </a:rPr>
-              <a:t>Missing LICENSE file</a:t>
-            </a:r>
-          </a:p>
-          <a:p>
-            <a:pPr algn="l">
-              <a:lnSpc>
-                <a:spcPct val="115000"/>
-              </a:lnSpc>
-              <a:spcAft>
-                <a:spcPts val="200"/>
-              </a:spcAft>
-            </a:pPr>
-            <a:r>
-              <a:rPr sz="950" b="0">
-                <a:solidFill>
-                  <a:srgbClr val="CBD5E1"/>
-                </a:solidFill>
-                <a:latin typeface="Segoe UI"/>
-              </a:rPr>
-              <a:t>No LICENSE ships with uld/, only a bare ST copyright comment.</a:t>
-            </a:r>
-          </a:p>
-        </p:txBody>
-      </p:sp>
+            <a:pPr algn="l"/>
+            <a:r>
+              <a:rPr lang="en-US" sz="1400">
+                <a:solidFill>
+                  <a:srgbClr val="475569"/>
+                </a:solidFill>
+                <a:latin typeface="Rockwell"/>
+              </a:rPr>
+              <a:t>Screenshot: menuconfig running for the NUCLEO-F401RE build.</a:t>
+            </a:r>
+          </a:p>
+        </p:txBody>
+      </p:sp>
+      <p:pic>
+        <p:nvPicPr>
+          <p:cNvPr id="7" name="Picture 6">
+            <a:extLst>
+              <a:ext uri="{FF2B5EF4-FFF2-40B4-BE49-F238E27FC236}">
+                <a16:creationId xmlns:a16="http://schemas.microsoft.com/office/drawing/2014/main" id="{DB894680-4039-79C9-F832-BEF35A8A74E7}"/>
+              </a:ext>
+            </a:extLst>
+          </p:cNvPr>
+          <p:cNvPicPr>
+            <a:picLocks noChangeAspect="1"/>
+          </p:cNvPicPr>
+          <p:nvPr/>
+        </p:nvPicPr>
+        <p:blipFill>
+          <a:blip r:embed="rId2"/>
+          <a:stretch>
+            <a:fillRect/>
+          </a:stretch>
+        </p:blipFill>
+        <p:spPr>
+          <a:xfrm>
+            <a:off x="4953000" y="2032000"/>
+            <a:ext cx="6604000" cy="3107430"/>
+          </a:xfrm>
+          <a:prstGeom prst="rect">
+            <a:avLst/>
+          </a:prstGeom>
+        </p:spPr>
+      </p:pic>
     </p:spTree>
+    <p:extLst>
+      <p:ext uri="{BB962C8B-B14F-4D97-AF65-F5344CB8AC3E}">
+        <p14:creationId xmlns:p14="http://schemas.microsoft.com/office/powerpoint/2010/main" val="2078008310"/>
+      </p:ext>
+    </p:extLst>
   </p:cSld>
   <p:clrMapOvr>
     <a:masterClrMapping/>
@@ -11206,14 +10293,14 @@
       </p:grpSpPr>
       <p:sp>
         <p:nvSpPr>
-          <p:cNvPr id="2" name="TextBox 1"/>
+          <p:cNvPr id="3" name="TextBox 2"/>
           <p:cNvSpPr txBox="1"/>
           <p:nvPr/>
         </p:nvSpPr>
         <p:spPr>
           <a:xfrm>
-            <a:off x="640080" y="365760"/>
-            <a:ext cx="7315200" cy="184666"/>
+            <a:off x="0" y="327392"/>
+            <a:ext cx="12192000" cy="815608"/>
           </a:xfrm>
           <a:prstGeom prst="rect">
             <a:avLst/>
@@ -11226,49 +10313,22 @@
           </a:bodyPr>
           <a:lstStyle/>
           <a:p>
-            <a:pPr algn="l">
+            <a:pPr algn="ctr"/>
+            <a:r>
+              <a:rPr lang="en-US" sz="2800" b="1" dirty="0">
+                <a:latin typeface="Rockwell" panose="02060603020205020403" pitchFamily="18" charset="0"/>
+              </a:rPr>
+              <a:t>CONCLUSION:</a:t>
+            </a:r>
+          </a:p>
+          <a:p>
+            <a:pPr algn="ctr">
               <a:spcAft>
                 <a:spcPts val="0"/>
               </a:spcAft>
             </a:pPr>
             <a:r>
-              <a:rPr sz="1200" b="1" dirty="0">
-                <a:latin typeface="Rockwell" panose="02060603020205020403" pitchFamily="18" charset="0"/>
-              </a:rPr>
-              <a:t>CONCLUSION</a:t>
-            </a:r>
-          </a:p>
-        </p:txBody>
-      </p:sp>
-      <p:sp>
-        <p:nvSpPr>
-          <p:cNvPr id="3" name="TextBox 2"/>
-          <p:cNvSpPr txBox="1"/>
-          <p:nvPr/>
-        </p:nvSpPr>
-        <p:spPr>
-          <a:xfrm>
-            <a:off x="640080" y="621792"/>
-            <a:ext cx="10058400" cy="384721"/>
-          </a:xfrm>
-          <a:prstGeom prst="rect">
-            <a:avLst/>
-          </a:prstGeom>
-          <a:noFill/>
-        </p:spPr>
-        <p:txBody>
-          <a:bodyPr wrap="square" lIns="0" tIns="0" rIns="0" bIns="0">
-            <a:spAutoFit/>
-          </a:bodyPr>
-          <a:lstStyle/>
-          <a:p>
-            <a:pPr algn="l">
-              <a:spcAft>
-                <a:spcPts val="0"/>
-              </a:spcAft>
-            </a:pPr>
-            <a:r>
-              <a:rPr sz="2500" b="1">
+              <a:rPr sz="2500" b="1" dirty="0">
                 <a:solidFill>
                   <a:srgbClr val="0F172A"/>
                 </a:solidFill>
@@ -11276,55 +10336,6 @@
               </a:rPr>
               <a:t>One Platform, One Workspace, One Driver Away</a:t>
             </a:r>
-          </a:p>
-        </p:txBody>
-      </p:sp>
-      <p:sp>
-        <p:nvSpPr>
-          <p:cNvPr id="4" name="Rounded Rectangle 3"/>
-          <p:cNvSpPr/>
-          <p:nvPr/>
-        </p:nvSpPr>
-        <p:spPr>
-          <a:xfrm>
-            <a:off x="640080" y="1243584"/>
-            <a:ext cx="822960" cy="36576"/>
-          </a:xfrm>
-          <a:prstGeom prst="roundRect">
-            <a:avLst>
-              <a:gd name="adj" fmla="val 50000"/>
-            </a:avLst>
-          </a:prstGeom>
-          <a:solidFill>
-            <a:srgbClr val="2563EB"/>
-          </a:solidFill>
-          <a:ln>
-            <a:noFill/>
-          </a:ln>
-          <a:effectLst/>
-        </p:spPr>
-        <p:style>
-          <a:lnRef idx="1">
-            <a:schemeClr val="accent1"/>
-          </a:lnRef>
-          <a:fillRef idx="3">
-            <a:schemeClr val="accent1"/>
-          </a:fillRef>
-          <a:effectRef idx="2">
-            <a:schemeClr val="accent1"/>
-          </a:effectRef>
-          <a:fontRef idx="minor">
-            <a:schemeClr val="lt1"/>
-          </a:fontRef>
-        </p:style>
-        <p:txBody>
-          <a:bodyPr rtlCol="0" anchor="ctr"/>
-          <a:lstStyle/>
-          <a:p>
-            <a:pPr algn="ctr"/>
-            <a:endParaRPr>
-              <a:latin typeface="Rockwell" panose="02060603020205020403" pitchFamily="18" charset="0"/>
-            </a:endParaRPr>
           </a:p>
         </p:txBody>
       </p:sp>
@@ -12035,6 +11046,76 @@
         </p:txBody>
       </p:sp>
     </p:spTree>
+  </p:cSld>
+  <p:clrMapOvr>
+    <a:masterClrMapping/>
+  </p:clrMapOvr>
+</p:sld>
+</file>
+
+<file path=ppt/slides/slide19.xml><?xml version="1.0" encoding="utf-8"?>
+<p:sld xmlns:a="http://schemas.openxmlformats.org/drawingml/2006/main" xmlns:r="http://schemas.openxmlformats.org/officeDocument/2006/relationships" xmlns:p="http://schemas.openxmlformats.org/presentationml/2006/main">
+  <p:cSld>
+    <p:spTree>
+      <p:nvGrpSpPr>
+        <p:cNvPr id="1" name=""/>
+        <p:cNvGrpSpPr/>
+        <p:nvPr/>
+      </p:nvGrpSpPr>
+      <p:grpSpPr>
+        <a:xfrm>
+          <a:off x="0" y="0"/>
+          <a:ext cx="0" cy="0"/>
+          <a:chOff x="0" y="0"/>
+          <a:chExt cx="0" cy="0"/>
+        </a:xfrm>
+      </p:grpSpPr>
+      <p:sp>
+        <p:nvSpPr>
+          <p:cNvPr id="2" name="TextBox 1">
+            <a:extLst>
+              <a:ext uri="{FF2B5EF4-FFF2-40B4-BE49-F238E27FC236}">
+                <a16:creationId xmlns:a16="http://schemas.microsoft.com/office/drawing/2014/main" id="{6B32E42A-52A6-C732-B73D-1D31E172C786}"/>
+              </a:ext>
+            </a:extLst>
+          </p:cNvPr>
+          <p:cNvSpPr txBox="1"/>
+          <p:nvPr/>
+        </p:nvSpPr>
+        <p:spPr>
+          <a:xfrm>
+            <a:off x="5175504" y="2724912"/>
+            <a:ext cx="1558440" cy="707886"/>
+          </a:xfrm>
+          <a:prstGeom prst="rect">
+            <a:avLst/>
+          </a:prstGeom>
+          <a:noFill/>
+        </p:spPr>
+        <p:txBody>
+          <a:bodyPr wrap="none" rtlCol="0">
+            <a:spAutoFit/>
+          </a:bodyPr>
+          <a:lstStyle/>
+          <a:p>
+            <a:r>
+              <a:rPr lang="en-GB" sz="4000" dirty="0">
+                <a:latin typeface="Rockwell" panose="02060603020205020403" pitchFamily="18" charset="0"/>
+              </a:rPr>
+              <a:t>Q &amp; A</a:t>
+            </a:r>
+            <a:endParaRPr lang="en-US" sz="4000" dirty="0">
+              <a:latin typeface="Rockwell" panose="02060603020205020403" pitchFamily="18" charset="0"/>
+            </a:endParaRPr>
+          </a:p>
+        </p:txBody>
+      </p:sp>
+    </p:spTree>
+    <p:extLst>
+      <p:ext uri="{BB962C8B-B14F-4D97-AF65-F5344CB8AC3E}">
+        <p14:creationId xmlns:p14="http://schemas.microsoft.com/office/powerpoint/2010/main" val="4161729647"/>
+      </p:ext>
+    </p:extLst>
   </p:cSld>
   <p:clrMapOvr>
     <a:masterClrMapping/>
@@ -12067,8 +11148,8 @@
         </p:nvSpPr>
         <p:spPr>
           <a:xfrm>
-            <a:off x="640080" y="621792"/>
-            <a:ext cx="10058400" cy="415498"/>
+            <a:off x="640080" y="301752"/>
+            <a:ext cx="10058400" cy="492443"/>
           </a:xfrm>
           <a:prstGeom prst="rect">
             <a:avLst/>
@@ -12087,7 +11168,7 @@
               </a:spcAft>
             </a:pPr>
             <a:r>
-              <a:rPr sz="2700" b="1" dirty="0">
+              <a:rPr sz="3200" b="1" dirty="0">
                 <a:solidFill>
                   <a:srgbClr val="0F172A"/>
                 </a:solidFill>
@@ -12096,27 +11177,33 @@
               <a:t>Agenda</a:t>
             </a:r>
             <a:r>
-              <a:rPr sz="2700" b="1" dirty="0">
+              <a:rPr lang="en-GB" sz="3200" b="1" dirty="0">
                 <a:solidFill>
                   <a:srgbClr val="0F172A"/>
                 </a:solidFill>
-                <a:latin typeface="Segoe UI"/>
-              </a:rPr>
-              <a:t> &amp; Presentation Roadmap</a:t>
-            </a:r>
-          </a:p>
-        </p:txBody>
-      </p:sp>
-      <p:sp>
-        <p:nvSpPr>
-          <p:cNvPr id="5" name="TextBox 4"/>
+                <a:latin typeface="Rockwell" panose="02060603020205020403" pitchFamily="18" charset="0"/>
+              </a:rPr>
+              <a:t>: What we will cover</a:t>
+            </a:r>
+            <a:endParaRPr sz="3200" b="1" dirty="0">
+              <a:solidFill>
+                <a:srgbClr val="0F172A"/>
+              </a:solidFill>
+              <a:latin typeface="Rockwell" panose="02060603020205020403" pitchFamily="18" charset="0"/>
+            </a:endParaRPr>
+          </a:p>
+        </p:txBody>
+      </p:sp>
+      <p:sp>
+        <p:nvSpPr>
+          <p:cNvPr id="7" name="TextBox 6"/>
           <p:cNvSpPr txBox="1"/>
           <p:nvPr/>
         </p:nvSpPr>
         <p:spPr>
           <a:xfrm>
-            <a:off x="640080" y="6446520"/>
-            <a:ext cx="6400800" cy="274320"/>
+            <a:off x="640080" y="1508760"/>
+            <a:ext cx="731520" cy="246221"/>
           </a:xfrm>
           <a:prstGeom prst="rect">
             <a:avLst/>
@@ -12135,27 +11222,24 @@
               </a:spcAft>
             </a:pPr>
             <a:r>
-              <a:rPr sz="900" b="0">
-                <a:solidFill>
-                  <a:srgbClr val="64748B"/>
-                </a:solidFill>
+              <a:rPr sz="1600" b="1">
                 <a:latin typeface="Segoe UI"/>
               </a:rPr>
-              <a:t>Zephyr on STM32 → the VL53L8CX Driver</a:t>
-            </a:r>
-          </a:p>
-        </p:txBody>
-      </p:sp>
-      <p:sp>
-        <p:nvSpPr>
-          <p:cNvPr id="7" name="TextBox 6"/>
+              <a:t>01</a:t>
+            </a:r>
+          </a:p>
+        </p:txBody>
+      </p:sp>
+      <p:sp>
+        <p:nvSpPr>
+          <p:cNvPr id="8" name="TextBox 7"/>
           <p:cNvSpPr txBox="1"/>
           <p:nvPr/>
         </p:nvSpPr>
         <p:spPr>
           <a:xfrm>
-            <a:off x="640080" y="1508760"/>
-            <a:ext cx="731520" cy="1097280"/>
+            <a:off x="1371600" y="1554480"/>
+            <a:ext cx="4602479" cy="777136"/>
           </a:xfrm>
           <a:prstGeom prst="rect">
             <a:avLst/>
@@ -12170,31 +11254,53 @@
           <a:p>
             <a:pPr algn="l">
               <a:spcAft>
-                <a:spcPts val="0"/>
-              </a:spcAft>
-            </a:pPr>
-            <a:r>
-              <a:rPr sz="2000" b="1">
-                <a:solidFill>
-                  <a:srgbClr val="E2E8F0"/>
-                </a:solidFill>
-                <a:latin typeface="Segoe UI"/>
-              </a:rPr>
-              <a:t>01</a:t>
-            </a:r>
-          </a:p>
-        </p:txBody>
-      </p:sp>
-      <p:sp>
-        <p:nvSpPr>
-          <p:cNvPr id="8" name="TextBox 7"/>
+                <a:spcPts val="300"/>
+              </a:spcAft>
+            </a:pPr>
+            <a:r>
+              <a:rPr sz="1600" b="1" dirty="0">
+                <a:solidFill>
+                  <a:srgbClr val="0F172A"/>
+                </a:solidFill>
+                <a:latin typeface="Rockwell" panose="02060603020205020403" pitchFamily="18" charset="0"/>
+              </a:rPr>
+              <a:t>What is Zephyr?</a:t>
+            </a:r>
+          </a:p>
+          <a:p>
+            <a:pPr algn="l">
+              <a:spcAft>
+                <a:spcPts val="300"/>
+              </a:spcAft>
+            </a:pPr>
+            <a:r>
+              <a:rPr lang="en-GB" sz="1600" b="0" dirty="0">
+                <a:solidFill>
+                  <a:srgbClr val="475569"/>
+                </a:solidFill>
+                <a:latin typeface="Rockwell" panose="02060603020205020403" pitchFamily="18" charset="0"/>
+              </a:rPr>
+              <a:t>A quick introduction to Zephyr and why it is more than just RTOS</a:t>
+            </a:r>
+            <a:endParaRPr sz="1600" b="0" dirty="0">
+              <a:solidFill>
+                <a:srgbClr val="475569"/>
+              </a:solidFill>
+              <a:latin typeface="Rockwell" panose="02060603020205020403" pitchFamily="18" charset="0"/>
+            </a:endParaRPr>
+          </a:p>
+        </p:txBody>
+      </p:sp>
+      <p:sp>
+        <p:nvSpPr>
+          <p:cNvPr id="9" name="TextBox 8"/>
           <p:cNvSpPr txBox="1"/>
           <p:nvPr/>
         </p:nvSpPr>
         <p:spPr>
           <a:xfrm>
-            <a:off x="1371600" y="1554480"/>
-            <a:ext cx="4602479" cy="569387"/>
+            <a:off x="640080" y="2606040"/>
+            <a:ext cx="731520" cy="246221"/>
           </a:xfrm>
           <a:prstGeom prst="rect">
             <a:avLst/>
@@ -12209,47 +11315,28 @@
           <a:p>
             <a:pPr algn="l">
               <a:spcAft>
-                <a:spcPts val="300"/>
-              </a:spcAft>
-            </a:pPr>
-            <a:r>
-              <a:rPr sz="1350" b="1" dirty="0">
-                <a:solidFill>
-                  <a:srgbClr val="0F172A"/>
-                </a:solidFill>
-                <a:latin typeface="Rockwell" panose="02060603020205020403" pitchFamily="18" charset="0"/>
-              </a:rPr>
-              <a:t>What is Zephyr RTOS?</a:t>
-            </a:r>
-          </a:p>
-          <a:p>
-            <a:pPr algn="l">
-              <a:spcAft>
-                <a:spcPts val="300"/>
-              </a:spcAft>
-            </a:pPr>
-            <a:r>
-              <a:rPr sz="1050" b="0" dirty="0">
-                <a:solidFill>
-                  <a:srgbClr val="475569"/>
-                </a:solidFill>
-                <a:latin typeface="Rockwell" panose="02060603020205020403" pitchFamily="18" charset="0"/>
-              </a:rPr>
-              <a:t>A scalable, open-source RTOS with layered architecture and hardware abstraction.</a:t>
-            </a:r>
-          </a:p>
-        </p:txBody>
-      </p:sp>
-      <p:sp>
-        <p:nvSpPr>
-          <p:cNvPr id="9" name="TextBox 8"/>
+                <a:spcPts val="0"/>
+              </a:spcAft>
+            </a:pPr>
+            <a:r>
+              <a:rPr sz="1600" b="1" dirty="0">
+                <a:latin typeface="Segoe UI"/>
+              </a:rPr>
+              <a:t>02</a:t>
+            </a:r>
+          </a:p>
+        </p:txBody>
+      </p:sp>
+      <p:sp>
+        <p:nvSpPr>
+          <p:cNvPr id="10" name="TextBox 9"/>
           <p:cNvSpPr txBox="1"/>
           <p:nvPr/>
         </p:nvSpPr>
         <p:spPr>
           <a:xfrm>
-            <a:off x="640080" y="2606040"/>
-            <a:ext cx="731520" cy="1097280"/>
+            <a:off x="1371600" y="2651760"/>
+            <a:ext cx="4602479" cy="777136"/>
           </a:xfrm>
           <a:prstGeom prst="rect">
             <a:avLst/>
@@ -12262,33 +11349,97 @@
           </a:bodyPr>
           <a:lstStyle/>
           <a:p>
-            <a:pPr algn="l">
-              <a:spcAft>
-                <a:spcPts val="0"/>
-              </a:spcAft>
-            </a:pPr>
-            <a:r>
-              <a:rPr sz="2000" b="1">
-                <a:solidFill>
-                  <a:srgbClr val="E2E8F0"/>
-                </a:solidFill>
-                <a:latin typeface="Segoe UI"/>
-              </a:rPr>
-              <a:t>02</a:t>
-            </a:r>
-          </a:p>
-        </p:txBody>
-      </p:sp>
-      <p:sp>
-        <p:nvSpPr>
-          <p:cNvPr id="10" name="TextBox 9"/>
+            <a:pPr>
+              <a:spcAft>
+                <a:spcPts val="300"/>
+              </a:spcAft>
+            </a:pPr>
+            <a:r>
+              <a:rPr sz="1600" b="1" dirty="0">
+                <a:solidFill>
+                  <a:srgbClr val="0F172A"/>
+                </a:solidFill>
+                <a:latin typeface="Rockwell" panose="02060603020205020403" pitchFamily="18" charset="0"/>
+              </a:rPr>
+              <a:t>Architecture &amp; Build Tooling</a:t>
+            </a:r>
+            <a:endParaRPr lang="en-GB" sz="1600" b="1" dirty="0">
+              <a:solidFill>
+                <a:srgbClr val="0F172A"/>
+              </a:solidFill>
+              <a:latin typeface="Rockwell" panose="02060603020205020403" pitchFamily="18" charset="0"/>
+            </a:endParaRPr>
+          </a:p>
+          <a:p>
+            <a:pPr>
+              <a:spcAft>
+                <a:spcPts val="300"/>
+              </a:spcAft>
+            </a:pPr>
+            <a:r>
+              <a:rPr lang="en-US" sz="1600" dirty="0">
+                <a:solidFill>
+                  <a:srgbClr val="475569"/>
+                </a:solidFill>
+                <a:latin typeface="Rockwell" panose="02060603020205020403" pitchFamily="18" charset="0"/>
+              </a:rPr>
+              <a:t>The architecture, </a:t>
+            </a:r>
+            <a:r>
+              <a:rPr lang="en-US" sz="1600" dirty="0" err="1">
+                <a:solidFill>
+                  <a:srgbClr val="475569"/>
+                </a:solidFill>
+                <a:latin typeface="Rockwell" panose="02060603020205020403" pitchFamily="18" charset="0"/>
+              </a:rPr>
+              <a:t>Kconfig</a:t>
+            </a:r>
+            <a:r>
+              <a:rPr lang="en-US" sz="1600" dirty="0">
+                <a:solidFill>
+                  <a:srgbClr val="475569"/>
+                </a:solidFill>
+                <a:latin typeface="Rockwell" panose="02060603020205020403" pitchFamily="18" charset="0"/>
+              </a:rPr>
+              <a:t>, </a:t>
+            </a:r>
+            <a:r>
+              <a:rPr lang="en-US" sz="1600" dirty="0" err="1">
+                <a:solidFill>
+                  <a:srgbClr val="475569"/>
+                </a:solidFill>
+                <a:latin typeface="Rockwell" panose="02060603020205020403" pitchFamily="18" charset="0"/>
+              </a:rPr>
+              <a:t>Devicetree</a:t>
+            </a:r>
+            <a:r>
+              <a:rPr lang="en-US" sz="1600" dirty="0">
+                <a:solidFill>
+                  <a:srgbClr val="475569"/>
+                </a:solidFill>
+                <a:latin typeface="Rockwell" panose="02060603020205020403" pitchFamily="18" charset="0"/>
+              </a:rPr>
+              <a:t> and build system</a:t>
+            </a:r>
+            <a:endParaRPr sz="1600" dirty="0">
+              <a:solidFill>
+                <a:srgbClr val="475569"/>
+              </a:solidFill>
+              <a:latin typeface="Rockwell" panose="02060603020205020403" pitchFamily="18" charset="0"/>
+            </a:endParaRPr>
+          </a:p>
+        </p:txBody>
+      </p:sp>
+      <p:sp>
+        <p:nvSpPr>
+          <p:cNvPr id="11" name="TextBox 10"/>
           <p:cNvSpPr txBox="1"/>
           <p:nvPr/>
         </p:nvSpPr>
         <p:spPr>
           <a:xfrm>
-            <a:off x="1371600" y="2651760"/>
-            <a:ext cx="4602479" cy="407804"/>
+            <a:off x="640080" y="3703320"/>
+            <a:ext cx="731520" cy="246221"/>
           </a:xfrm>
           <a:prstGeom prst="rect">
             <a:avLst/>
@@ -12303,101 +11454,28 @@
           <a:p>
             <a:pPr algn="l">
               <a:spcAft>
-                <a:spcPts val="300"/>
-              </a:spcAft>
-            </a:pPr>
-            <a:r>
-              <a:rPr sz="1350" b="1" dirty="0">
-                <a:solidFill>
-                  <a:srgbClr val="0F172A"/>
-                </a:solidFill>
-                <a:latin typeface="Rockwell" panose="02060603020205020403" pitchFamily="18" charset="0"/>
-              </a:rPr>
-              <a:t>Architecture &amp; Build Tooling</a:t>
-            </a:r>
-          </a:p>
-          <a:p>
-            <a:pPr algn="l">
-              <a:spcAft>
-                <a:spcPts val="300"/>
-              </a:spcAft>
-            </a:pPr>
-            <a:r>
-              <a:rPr sz="1050" b="0" dirty="0">
-                <a:solidFill>
-                  <a:srgbClr val="475569"/>
-                </a:solidFill>
-                <a:latin typeface="Rockwell" panose="02060603020205020403" pitchFamily="18" charset="0"/>
-              </a:rPr>
-              <a:t>The layered stack, </a:t>
-            </a:r>
-            <a:r>
-              <a:rPr sz="1050" b="0" dirty="0" err="1">
-                <a:solidFill>
-                  <a:srgbClr val="475569"/>
-                </a:solidFill>
-                <a:latin typeface="Rockwell" panose="02060603020205020403" pitchFamily="18" charset="0"/>
-              </a:rPr>
-              <a:t>Devicetree</a:t>
-            </a:r>
-            <a:r>
-              <a:rPr sz="1050" b="0" dirty="0">
-                <a:solidFill>
-                  <a:srgbClr val="475569"/>
-                </a:solidFill>
-                <a:latin typeface="Rockwell" panose="02060603020205020403" pitchFamily="18" charset="0"/>
-              </a:rPr>
-              <a:t>, </a:t>
-            </a:r>
-            <a:r>
-              <a:rPr sz="1050" b="0" dirty="0" err="1">
-                <a:solidFill>
-                  <a:srgbClr val="475569"/>
-                </a:solidFill>
-                <a:latin typeface="Rockwell" panose="02060603020205020403" pitchFamily="18" charset="0"/>
-              </a:rPr>
-              <a:t>Kconfig</a:t>
-            </a:r>
-            <a:r>
-              <a:rPr sz="1050" b="0" dirty="0">
-                <a:solidFill>
-                  <a:srgbClr val="475569"/>
-                </a:solidFill>
-                <a:latin typeface="Rockwell" panose="02060603020205020403" pitchFamily="18" charset="0"/>
-              </a:rPr>
-              <a:t>, and the west/</a:t>
-            </a:r>
-            <a:r>
-              <a:rPr sz="1050" b="0" dirty="0" err="1">
-                <a:solidFill>
-                  <a:srgbClr val="475569"/>
-                </a:solidFill>
-                <a:latin typeface="Rockwell" panose="02060603020205020403" pitchFamily="18" charset="0"/>
-              </a:rPr>
-              <a:t>CMake</a:t>
-            </a:r>
-            <a:r>
-              <a:rPr sz="1050" b="0" dirty="0">
-                <a:solidFill>
-                  <a:srgbClr val="475569"/>
-                </a:solidFill>
-                <a:latin typeface="Rockwell" panose="02060603020205020403" pitchFamily="18" charset="0"/>
-              </a:rPr>
-              <a:t> pipeline.</a:t>
-            </a:r>
-          </a:p>
-        </p:txBody>
-      </p:sp>
-      <p:sp>
-        <p:nvSpPr>
-          <p:cNvPr id="11" name="TextBox 10"/>
+                <a:spcPts val="0"/>
+              </a:spcAft>
+            </a:pPr>
+            <a:r>
+              <a:rPr sz="1600" b="1">
+                <a:latin typeface="Segoe UI"/>
+              </a:rPr>
+              <a:t>03</a:t>
+            </a:r>
+          </a:p>
+        </p:txBody>
+      </p:sp>
+      <p:sp>
+        <p:nvSpPr>
+          <p:cNvPr id="12" name="TextBox 11"/>
           <p:cNvSpPr txBox="1"/>
           <p:nvPr/>
         </p:nvSpPr>
         <p:spPr>
           <a:xfrm>
-            <a:off x="640080" y="3703320"/>
-            <a:ext cx="731520" cy="1097280"/>
+            <a:off x="1371600" y="3749040"/>
+            <a:ext cx="4602479" cy="777136"/>
           </a:xfrm>
           <a:prstGeom prst="rect">
             <a:avLst/>
@@ -12412,31 +11490,74 @@
           <a:p>
             <a:pPr algn="l">
               <a:spcAft>
-                <a:spcPts val="0"/>
-              </a:spcAft>
-            </a:pPr>
-            <a:r>
-              <a:rPr sz="2000" b="1">
-                <a:solidFill>
-                  <a:srgbClr val="E2E8F0"/>
-                </a:solidFill>
-                <a:latin typeface="Segoe UI"/>
-              </a:rPr>
-              <a:t>03</a:t>
-            </a:r>
-          </a:p>
-        </p:txBody>
-      </p:sp>
-      <p:sp>
-        <p:nvSpPr>
-          <p:cNvPr id="12" name="TextBox 11"/>
+                <a:spcPts val="300"/>
+              </a:spcAft>
+            </a:pPr>
+            <a:r>
+              <a:rPr sz="1600" b="1" dirty="0">
+                <a:solidFill>
+                  <a:srgbClr val="0F172A"/>
+                </a:solidFill>
+                <a:latin typeface="Rockwell" panose="02060603020205020403" pitchFamily="18" charset="0"/>
+              </a:rPr>
+              <a:t>What is West?</a:t>
+            </a:r>
+          </a:p>
+          <a:p>
+            <a:pPr algn="l">
+              <a:spcAft>
+                <a:spcPts val="300"/>
+              </a:spcAft>
+            </a:pPr>
+            <a:r>
+              <a:rPr lang="en-GB" sz="1600" dirty="0">
+                <a:solidFill>
+                  <a:srgbClr val="475569"/>
+                </a:solidFill>
+                <a:latin typeface="Rockwell" panose="02060603020205020403" pitchFamily="18" charset="0"/>
+              </a:rPr>
+              <a:t>How west </a:t>
+            </a:r>
+            <a:r>
+              <a:rPr lang="en-GB" sz="1600" dirty="0" err="1">
+                <a:solidFill>
+                  <a:srgbClr val="475569"/>
+                </a:solidFill>
+                <a:latin typeface="Rockwell" panose="02060603020205020403" pitchFamily="18" charset="0"/>
+              </a:rPr>
+              <a:t>manges</a:t>
+            </a:r>
+            <a:r>
+              <a:rPr lang="en-GB" sz="1600" dirty="0">
+                <a:solidFill>
+                  <a:srgbClr val="475569"/>
+                </a:solidFill>
+                <a:latin typeface="Rockwell" panose="02060603020205020403" pitchFamily="18" charset="0"/>
+              </a:rPr>
+              <a:t> the Zephyr workspace and its repositories</a:t>
+            </a:r>
+            <a:r>
+              <a:rPr sz="1600" b="0" dirty="0">
+                <a:solidFill>
+                  <a:srgbClr val="475569"/>
+                </a:solidFill>
+                <a:latin typeface="Rockwell" panose="02060603020205020403" pitchFamily="18" charset="0"/>
+              </a:rPr>
+              <a:t>.</a:t>
+            </a:r>
+          </a:p>
+        </p:txBody>
+      </p:sp>
+      <p:sp>
+        <p:nvSpPr>
+          <p:cNvPr id="13" name="TextBox 12"/>
           <p:cNvSpPr txBox="1"/>
           <p:nvPr/>
         </p:nvSpPr>
         <p:spPr>
           <a:xfrm>
-            <a:off x="1371600" y="3749040"/>
-            <a:ext cx="4602479" cy="407804"/>
+            <a:off x="640080" y="4800600"/>
+            <a:ext cx="731520" cy="246221"/>
           </a:xfrm>
           <a:prstGeom prst="rect">
             <a:avLst/>
@@ -12451,47 +11572,28 @@
           <a:p>
             <a:pPr algn="l">
               <a:spcAft>
-                <a:spcPts val="300"/>
-              </a:spcAft>
-            </a:pPr>
-            <a:r>
-              <a:rPr sz="1350" b="1" dirty="0">
-                <a:solidFill>
-                  <a:srgbClr val="0F172A"/>
-                </a:solidFill>
-                <a:latin typeface="Rockwell" panose="02060603020205020403" pitchFamily="18" charset="0"/>
-              </a:rPr>
-              <a:t>What is West?</a:t>
-            </a:r>
-          </a:p>
-          <a:p>
-            <a:pPr algn="l">
-              <a:spcAft>
-                <a:spcPts val="300"/>
-              </a:spcAft>
-            </a:pPr>
-            <a:r>
-              <a:rPr sz="1050" b="0" dirty="0">
-                <a:solidFill>
-                  <a:srgbClr val="475569"/>
-                </a:solidFill>
-                <a:latin typeface="Rockwell" panose="02060603020205020403" pitchFamily="18" charset="0"/>
-              </a:rPr>
-              <a:t>The manifest meta-tool, and our app-as-manifest (T2) topology.</a:t>
-            </a:r>
-          </a:p>
-        </p:txBody>
-      </p:sp>
-      <p:sp>
-        <p:nvSpPr>
-          <p:cNvPr id="13" name="TextBox 12"/>
+                <a:spcPts val="0"/>
+              </a:spcAft>
+            </a:pPr>
+            <a:r>
+              <a:rPr sz="1600" b="1">
+                <a:latin typeface="Segoe UI"/>
+              </a:rPr>
+              <a:t>04</a:t>
+            </a:r>
+          </a:p>
+        </p:txBody>
+      </p:sp>
+      <p:sp>
+        <p:nvSpPr>
+          <p:cNvPr id="14" name="TextBox 13"/>
           <p:cNvSpPr txBox="1"/>
           <p:nvPr/>
         </p:nvSpPr>
         <p:spPr>
           <a:xfrm>
-            <a:off x="640080" y="4800600"/>
-            <a:ext cx="731520" cy="1097280"/>
+            <a:off x="1371600" y="4846320"/>
+            <a:ext cx="4602479" cy="777136"/>
           </a:xfrm>
           <a:prstGeom prst="rect">
             <a:avLst/>
@@ -12506,31 +11608,53 @@
           <a:p>
             <a:pPr algn="l">
               <a:spcAft>
-                <a:spcPts val="0"/>
-              </a:spcAft>
-            </a:pPr>
-            <a:r>
-              <a:rPr sz="2000" b="1">
-                <a:solidFill>
-                  <a:srgbClr val="E2E8F0"/>
-                </a:solidFill>
-                <a:latin typeface="Segoe UI"/>
-              </a:rPr>
-              <a:t>04</a:t>
-            </a:r>
-          </a:p>
-        </p:txBody>
-      </p:sp>
-      <p:sp>
-        <p:nvSpPr>
-          <p:cNvPr id="14" name="TextBox 13"/>
+                <a:spcPts val="300"/>
+              </a:spcAft>
+            </a:pPr>
+            <a:r>
+              <a:rPr sz="1600" b="1" dirty="0">
+                <a:solidFill>
+                  <a:srgbClr val="0F172A"/>
+                </a:solidFill>
+                <a:latin typeface="Rockwell" panose="02060603020205020403" pitchFamily="18" charset="0"/>
+              </a:rPr>
+              <a:t>Zephyr's Folder Structure</a:t>
+            </a:r>
+          </a:p>
+          <a:p>
+            <a:pPr algn="l">
+              <a:spcAft>
+                <a:spcPts val="300"/>
+              </a:spcAft>
+            </a:pPr>
+            <a:r>
+              <a:rPr lang="en-GB" sz="1600" b="0" dirty="0">
+                <a:solidFill>
+                  <a:srgbClr val="475569"/>
+                </a:solidFill>
+                <a:latin typeface="Rockwell" panose="02060603020205020403" pitchFamily="18" charset="0"/>
+              </a:rPr>
+              <a:t>Where the kernel, drivers, boards, subsystems lives</a:t>
+            </a:r>
+            <a:endParaRPr sz="1600" b="0" dirty="0">
+              <a:solidFill>
+                <a:srgbClr val="475569"/>
+              </a:solidFill>
+              <a:latin typeface="Rockwell" panose="02060603020205020403" pitchFamily="18" charset="0"/>
+            </a:endParaRPr>
+          </a:p>
+        </p:txBody>
+      </p:sp>
+      <p:sp>
+        <p:nvSpPr>
+          <p:cNvPr id="15" name="TextBox 14"/>
           <p:cNvSpPr txBox="1"/>
           <p:nvPr/>
         </p:nvSpPr>
         <p:spPr>
           <a:xfrm>
-            <a:off x="1371600" y="4846320"/>
-            <a:ext cx="4602479" cy="407804"/>
+            <a:off x="6217919" y="1508760"/>
+            <a:ext cx="731520" cy="246221"/>
           </a:xfrm>
           <a:prstGeom prst="rect">
             <a:avLst/>
@@ -12545,101 +11669,28 @@
           <a:p>
             <a:pPr algn="l">
               <a:spcAft>
-                <a:spcPts val="300"/>
-              </a:spcAft>
-            </a:pPr>
-            <a:r>
-              <a:rPr sz="1350" b="1" dirty="0">
-                <a:solidFill>
-                  <a:srgbClr val="0F172A"/>
-                </a:solidFill>
-                <a:latin typeface="Rockwell" panose="02060603020205020403" pitchFamily="18" charset="0"/>
-              </a:rPr>
-              <a:t>Zephyr's Folder Structure</a:t>
-            </a:r>
-          </a:p>
-          <a:p>
-            <a:pPr algn="l">
-              <a:spcAft>
-                <a:spcPts val="300"/>
-              </a:spcAft>
-            </a:pPr>
-            <a:r>
-              <a:rPr sz="1050" b="0" dirty="0">
-                <a:solidFill>
-                  <a:srgbClr val="475569"/>
-                </a:solidFill>
-                <a:latin typeface="Rockwell" panose="02060603020205020403" pitchFamily="18" charset="0"/>
-              </a:rPr>
-              <a:t>kernel/, arch/, drivers/, boards/, </a:t>
-            </a:r>
-            <a:r>
-              <a:rPr sz="1050" b="0" dirty="0" err="1">
-                <a:solidFill>
-                  <a:srgbClr val="475569"/>
-                </a:solidFill>
-                <a:latin typeface="Rockwell" panose="02060603020205020403" pitchFamily="18" charset="0"/>
-              </a:rPr>
-              <a:t>dts</a:t>
-            </a:r>
-            <a:r>
-              <a:rPr sz="1050" b="0" dirty="0">
-                <a:solidFill>
-                  <a:srgbClr val="475569"/>
-                </a:solidFill>
-                <a:latin typeface="Rockwell" panose="02060603020205020403" pitchFamily="18" charset="0"/>
-              </a:rPr>
-              <a:t>/, </a:t>
-            </a:r>
-            <a:r>
-              <a:rPr sz="1050" b="0" dirty="0" err="1">
-                <a:solidFill>
-                  <a:srgbClr val="475569"/>
-                </a:solidFill>
-                <a:latin typeface="Rockwell" panose="02060603020205020403" pitchFamily="18" charset="0"/>
-              </a:rPr>
-              <a:t>subsys</a:t>
-            </a:r>
-            <a:r>
-              <a:rPr sz="1050" b="0" dirty="0">
-                <a:solidFill>
-                  <a:srgbClr val="475569"/>
-                </a:solidFill>
-                <a:latin typeface="Rockwell" panose="02060603020205020403" pitchFamily="18" charset="0"/>
-              </a:rPr>
-              <a:t>/ — and </a:t>
-            </a:r>
-            <a:r>
-              <a:rPr sz="1050" b="0" dirty="0" err="1">
-                <a:solidFill>
-                  <a:srgbClr val="475569"/>
-                </a:solidFill>
-                <a:latin typeface="Rockwell" panose="02060603020205020403" pitchFamily="18" charset="0"/>
-              </a:rPr>
-              <a:t>Kconfig</a:t>
-            </a:r>
-            <a:r>
-              <a:rPr sz="1050" b="0" dirty="0">
-                <a:solidFill>
-                  <a:srgbClr val="475569"/>
-                </a:solidFill>
-                <a:latin typeface="Rockwell" panose="02060603020205020403" pitchFamily="18" charset="0"/>
-              </a:rPr>
-              <a:t>.</a:t>
-            </a:r>
-          </a:p>
-        </p:txBody>
-      </p:sp>
-      <p:sp>
-        <p:nvSpPr>
-          <p:cNvPr id="15" name="TextBox 14"/>
+                <a:spcPts val="0"/>
+              </a:spcAft>
+            </a:pPr>
+            <a:r>
+              <a:rPr sz="1600" b="1">
+                <a:latin typeface="Segoe UI"/>
+              </a:rPr>
+              <a:t>05</a:t>
+            </a:r>
+          </a:p>
+        </p:txBody>
+      </p:sp>
+      <p:sp>
+        <p:nvSpPr>
+          <p:cNvPr id="16" name="TextBox 15"/>
           <p:cNvSpPr txBox="1"/>
           <p:nvPr/>
         </p:nvSpPr>
         <p:spPr>
           <a:xfrm>
-            <a:off x="6217919" y="1508760"/>
-            <a:ext cx="731520" cy="1097280"/>
+            <a:off x="6949439" y="1554480"/>
+            <a:ext cx="4602479" cy="777136"/>
           </a:xfrm>
           <a:prstGeom prst="rect">
             <a:avLst/>
@@ -12654,31 +11705,65 @@
           <a:p>
             <a:pPr algn="l">
               <a:spcAft>
-                <a:spcPts val="0"/>
-              </a:spcAft>
-            </a:pPr>
-            <a:r>
-              <a:rPr sz="2000" b="1">
-                <a:solidFill>
-                  <a:srgbClr val="E2E8F0"/>
-                </a:solidFill>
-                <a:latin typeface="Segoe UI"/>
-              </a:rPr>
-              <a:t>05</a:t>
-            </a:r>
-          </a:p>
-        </p:txBody>
-      </p:sp>
-      <p:sp>
-        <p:nvSpPr>
-          <p:cNvPr id="16" name="TextBox 15"/>
+                <a:spcPts val="300"/>
+              </a:spcAft>
+            </a:pPr>
+            <a:r>
+              <a:rPr sz="1600" b="1" dirty="0">
+                <a:solidFill>
+                  <a:srgbClr val="0F172A"/>
+                </a:solidFill>
+                <a:latin typeface="Rockwell" panose="02060603020205020403" pitchFamily="18" charset="0"/>
+              </a:rPr>
+              <a:t>What is a Module?</a:t>
+            </a:r>
+          </a:p>
+          <a:p>
+            <a:pPr algn="l">
+              <a:spcAft>
+                <a:spcPts val="300"/>
+              </a:spcAft>
+            </a:pPr>
+            <a:r>
+              <a:rPr sz="1600" b="0" dirty="0">
+                <a:solidFill>
+                  <a:srgbClr val="475569"/>
+                </a:solidFill>
+                <a:latin typeface="Rockwell" panose="02060603020205020403" pitchFamily="18" charset="0"/>
+              </a:rPr>
+              <a:t>How </a:t>
+            </a:r>
+            <a:r>
+              <a:rPr lang="en-GB" sz="1600" b="0" dirty="0">
+                <a:solidFill>
+                  <a:srgbClr val="475569"/>
+                </a:solidFill>
+                <a:latin typeface="Rockwell" panose="02060603020205020403" pitchFamily="18" charset="0"/>
+              </a:rPr>
+              <a:t>external code such as HALs and sensor drivers are integrated</a:t>
+            </a:r>
+            <a:r>
+              <a:rPr sz="1600" b="0" dirty="0">
+                <a:solidFill>
+                  <a:srgbClr val="475569"/>
+                </a:solidFill>
+                <a:latin typeface="Rockwell" panose="02060603020205020403" pitchFamily="18" charset="0"/>
+              </a:rPr>
+              <a:t>.</a:t>
+            </a:r>
+          </a:p>
+        </p:txBody>
+      </p:sp>
+      <p:sp>
+        <p:nvSpPr>
+          <p:cNvPr id="17" name="TextBox 16"/>
           <p:cNvSpPr txBox="1"/>
           <p:nvPr/>
         </p:nvSpPr>
         <p:spPr>
           <a:xfrm>
-            <a:off x="6949439" y="1554480"/>
-            <a:ext cx="4602479" cy="407804"/>
+            <a:off x="6217919" y="2606040"/>
+            <a:ext cx="731520" cy="246221"/>
           </a:xfrm>
           <a:prstGeom prst="rect">
             <a:avLst/>
@@ -12693,65 +11778,28 @@
           <a:p>
             <a:pPr algn="l">
               <a:spcAft>
-                <a:spcPts val="300"/>
-              </a:spcAft>
-            </a:pPr>
-            <a:r>
-              <a:rPr sz="1350" b="1" dirty="0">
-                <a:solidFill>
-                  <a:srgbClr val="0F172A"/>
-                </a:solidFill>
-                <a:latin typeface="Rockwell" panose="02060603020205020403" pitchFamily="18" charset="0"/>
-              </a:rPr>
-              <a:t>What is a Module?</a:t>
-            </a:r>
-          </a:p>
-          <a:p>
-            <a:pPr algn="l">
-              <a:spcAft>
-                <a:spcPts val="300"/>
-              </a:spcAft>
-            </a:pPr>
-            <a:r>
-              <a:rPr sz="1050" b="0" dirty="0">
-                <a:solidFill>
-                  <a:srgbClr val="475569"/>
-                </a:solidFill>
-                <a:latin typeface="Rockwell" panose="02060603020205020403" pitchFamily="18" charset="0"/>
-              </a:rPr>
-              <a:t>How vendor HALs and our own driver plug into the build via </a:t>
-            </a:r>
-            <a:r>
-              <a:rPr sz="1050" b="0" dirty="0" err="1">
-                <a:solidFill>
-                  <a:srgbClr val="475569"/>
-                </a:solidFill>
-                <a:latin typeface="Rockwell" panose="02060603020205020403" pitchFamily="18" charset="0"/>
-              </a:rPr>
-              <a:t>module.yml</a:t>
-            </a:r>
-            <a:r>
-              <a:rPr sz="1050" b="0" dirty="0">
-                <a:solidFill>
-                  <a:srgbClr val="475569"/>
-                </a:solidFill>
-                <a:latin typeface="Rockwell" panose="02060603020205020403" pitchFamily="18" charset="0"/>
-              </a:rPr>
-              <a:t>.</a:t>
-            </a:r>
-          </a:p>
-        </p:txBody>
-      </p:sp>
-      <p:sp>
-        <p:nvSpPr>
-          <p:cNvPr id="17" name="TextBox 16"/>
+                <a:spcPts val="0"/>
+              </a:spcAft>
+            </a:pPr>
+            <a:r>
+              <a:rPr sz="1600" b="1">
+                <a:latin typeface="Segoe UI"/>
+              </a:rPr>
+              <a:t>06</a:t>
+            </a:r>
+          </a:p>
+        </p:txBody>
+      </p:sp>
+      <p:sp>
+        <p:nvSpPr>
+          <p:cNvPr id="18" name="TextBox 17"/>
           <p:cNvSpPr txBox="1"/>
           <p:nvPr/>
         </p:nvSpPr>
         <p:spPr>
           <a:xfrm>
-            <a:off x="6217919" y="2606040"/>
-            <a:ext cx="731520" cy="1097280"/>
+            <a:off x="6949439" y="2651760"/>
+            <a:ext cx="4602479" cy="777136"/>
           </a:xfrm>
           <a:prstGeom prst="rect">
             <a:avLst/>
@@ -12766,31 +11814,83 @@
           <a:p>
             <a:pPr algn="l">
               <a:spcAft>
-                <a:spcPts val="0"/>
-              </a:spcAft>
-            </a:pPr>
-            <a:r>
-              <a:rPr sz="2000" b="1">
-                <a:solidFill>
-                  <a:srgbClr val="E2E8F0"/>
-                </a:solidFill>
-                <a:latin typeface="Segoe UI"/>
-              </a:rPr>
-              <a:t>06</a:t>
-            </a:r>
-          </a:p>
-        </p:txBody>
-      </p:sp>
-      <p:sp>
-        <p:nvSpPr>
-          <p:cNvPr id="18" name="TextBox 17"/>
+                <a:spcPts val="300"/>
+              </a:spcAft>
+            </a:pPr>
+            <a:r>
+              <a:rPr sz="1600" b="1" dirty="0">
+                <a:solidFill>
+                  <a:srgbClr val="0F172A"/>
+                </a:solidFill>
+                <a:latin typeface="Rockwell" panose="02060603020205020403" pitchFamily="18" charset="0"/>
+              </a:rPr>
+              <a:t>Our Workspace</a:t>
+            </a:r>
+          </a:p>
+          <a:p>
+            <a:pPr algn="l">
+              <a:spcAft>
+                <a:spcPts val="300"/>
+              </a:spcAft>
+            </a:pPr>
+            <a:r>
+              <a:rPr lang="en-GB" sz="1600" b="0" dirty="0">
+                <a:solidFill>
+                  <a:srgbClr val="475569"/>
+                </a:solidFill>
+                <a:latin typeface="Rockwell" panose="02060603020205020403" pitchFamily="18" charset="0"/>
+              </a:rPr>
+              <a:t>How </a:t>
+            </a:r>
+            <a:r>
+              <a:rPr sz="1600" b="0" dirty="0" err="1">
+                <a:solidFill>
+                  <a:srgbClr val="475569"/>
+                </a:solidFill>
+                <a:latin typeface="Rockwell" panose="02060603020205020403" pitchFamily="18" charset="0"/>
+              </a:rPr>
+              <a:t>zephyr_app</a:t>
+            </a:r>
+            <a:r>
+              <a:rPr sz="1600" b="0" dirty="0">
+                <a:solidFill>
+                  <a:srgbClr val="475569"/>
+                </a:solidFill>
+                <a:latin typeface="Rockwell" panose="02060603020205020403" pitchFamily="18" charset="0"/>
+              </a:rPr>
+              <a:t>, zephyr/, modules/, bootloader/ </a:t>
+            </a:r>
+            <a:r>
+              <a:rPr lang="en-GB" sz="1600" dirty="0">
+                <a:solidFill>
+                  <a:srgbClr val="475569"/>
+                </a:solidFill>
+                <a:latin typeface="Rockwell" panose="02060603020205020403" pitchFamily="18" charset="0"/>
+              </a:rPr>
+              <a:t>fit together</a:t>
+            </a:r>
+            <a:r>
+              <a:rPr sz="1600" b="0" dirty="0">
+                <a:solidFill>
+                  <a:srgbClr val="475569"/>
+                </a:solidFill>
+                <a:latin typeface="Rockwell" panose="02060603020205020403" pitchFamily="18" charset="0"/>
+              </a:rPr>
+              <a:t>.</a:t>
+            </a:r>
+          </a:p>
+        </p:txBody>
+      </p:sp>
+      <p:sp>
+        <p:nvSpPr>
+          <p:cNvPr id="19" name="TextBox 18"/>
           <p:cNvSpPr txBox="1"/>
           <p:nvPr/>
         </p:nvSpPr>
         <p:spPr>
           <a:xfrm>
-            <a:off x="6949439" y="2651760"/>
-            <a:ext cx="4602479" cy="407804"/>
+            <a:off x="6217919" y="3703320"/>
+            <a:ext cx="731520" cy="246221"/>
           </a:xfrm>
           <a:prstGeom prst="rect">
             <a:avLst/>
@@ -12805,56 +11905,28 @@
           <a:p>
             <a:pPr algn="l">
               <a:spcAft>
-                <a:spcPts val="300"/>
-              </a:spcAft>
-            </a:pPr>
-            <a:r>
-              <a:rPr sz="1350" b="1" dirty="0">
-                <a:solidFill>
-                  <a:srgbClr val="0F172A"/>
-                </a:solidFill>
-                <a:latin typeface="Rockwell" panose="02060603020205020403" pitchFamily="18" charset="0"/>
-              </a:rPr>
-              <a:t>Our Workspace Layout</a:t>
-            </a:r>
-          </a:p>
-          <a:p>
-            <a:pPr algn="l">
-              <a:spcAft>
-                <a:spcPts val="300"/>
-              </a:spcAft>
-            </a:pPr>
-            <a:r>
-              <a:rPr sz="1050" b="0" dirty="0" err="1">
-                <a:solidFill>
-                  <a:srgbClr val="475569"/>
-                </a:solidFill>
-                <a:latin typeface="Rockwell" panose="02060603020205020403" pitchFamily="18" charset="0"/>
-              </a:rPr>
-              <a:t>zephyr_app</a:t>
-            </a:r>
-            <a:r>
-              <a:rPr sz="1050" b="0" dirty="0">
-                <a:solidFill>
-                  <a:srgbClr val="475569"/>
-                </a:solidFill>
-                <a:latin typeface="Rockwell" panose="02060603020205020403" pitchFamily="18" charset="0"/>
-              </a:rPr>
-              <a:t>, zephyr/, modules/, bootloader/ — as they actually sit on disk.</a:t>
-            </a:r>
-          </a:p>
-        </p:txBody>
-      </p:sp>
-      <p:sp>
-        <p:nvSpPr>
-          <p:cNvPr id="19" name="TextBox 18"/>
+                <a:spcPts val="0"/>
+              </a:spcAft>
+            </a:pPr>
+            <a:r>
+              <a:rPr sz="1600" b="1">
+                <a:latin typeface="Segoe UI"/>
+              </a:rPr>
+              <a:t>07</a:t>
+            </a:r>
+          </a:p>
+        </p:txBody>
+      </p:sp>
+      <p:sp>
+        <p:nvSpPr>
+          <p:cNvPr id="20" name="TextBox 19"/>
           <p:cNvSpPr txBox="1"/>
           <p:nvPr/>
         </p:nvSpPr>
         <p:spPr>
           <a:xfrm>
-            <a:off x="6217919" y="3703320"/>
-            <a:ext cx="731520" cy="1097280"/>
+            <a:off x="6949439" y="3749040"/>
+            <a:ext cx="4602479" cy="777136"/>
           </a:xfrm>
           <a:prstGeom prst="rect">
             <a:avLst/>
@@ -12869,31 +11941,53 @@
           <a:p>
             <a:pPr algn="l">
               <a:spcAft>
-                <a:spcPts val="0"/>
-              </a:spcAft>
-            </a:pPr>
-            <a:r>
-              <a:rPr sz="2000" b="1">
-                <a:solidFill>
-                  <a:srgbClr val="E2E8F0"/>
-                </a:solidFill>
-                <a:latin typeface="Segoe UI"/>
-              </a:rPr>
-              <a:t>07</a:t>
-            </a:r>
-          </a:p>
-        </p:txBody>
-      </p:sp>
-      <p:sp>
-        <p:nvSpPr>
-          <p:cNvPr id="20" name="TextBox 19"/>
+                <a:spcPts val="300"/>
+              </a:spcAft>
+            </a:pPr>
+            <a:r>
+              <a:rPr sz="1600" b="1" dirty="0">
+                <a:solidFill>
+                  <a:srgbClr val="0F172A"/>
+                </a:solidFill>
+                <a:latin typeface="Rockwell" panose="02060603020205020403" pitchFamily="18" charset="0"/>
+              </a:rPr>
+              <a:t>VL53L8CX Driver Status</a:t>
+            </a:r>
+          </a:p>
+          <a:p>
+            <a:pPr algn="l">
+              <a:spcAft>
+                <a:spcPts val="300"/>
+              </a:spcAft>
+            </a:pPr>
+            <a:r>
+              <a:rPr lang="en-GB" sz="1600" b="0" dirty="0">
+                <a:solidFill>
+                  <a:srgbClr val="475569"/>
+                </a:solidFill>
+                <a:latin typeface="Rockwell" panose="02060603020205020403" pitchFamily="18" charset="0"/>
+              </a:rPr>
+              <a:t>Why we need the driver and how we integrate with zephyr</a:t>
+            </a:r>
+            <a:endParaRPr sz="1600" b="0" dirty="0">
+              <a:solidFill>
+                <a:srgbClr val="475569"/>
+              </a:solidFill>
+              <a:latin typeface="Rockwell" panose="02060603020205020403" pitchFamily="18" charset="0"/>
+            </a:endParaRPr>
+          </a:p>
+        </p:txBody>
+      </p:sp>
+      <p:sp>
+        <p:nvSpPr>
+          <p:cNvPr id="21" name="TextBox 20"/>
           <p:cNvSpPr txBox="1"/>
           <p:nvPr/>
         </p:nvSpPr>
         <p:spPr>
           <a:xfrm>
-            <a:off x="6949439" y="3749040"/>
-            <a:ext cx="4602479" cy="407804"/>
+            <a:off x="6217919" y="4800600"/>
+            <a:ext cx="731520" cy="246221"/>
           </a:xfrm>
           <a:prstGeom prst="rect">
             <a:avLst/>
@@ -12908,47 +12002,28 @@
           <a:p>
             <a:pPr algn="l">
               <a:spcAft>
-                <a:spcPts val="300"/>
-              </a:spcAft>
-            </a:pPr>
-            <a:r>
-              <a:rPr sz="1350" b="1" dirty="0">
-                <a:solidFill>
-                  <a:srgbClr val="0F172A"/>
-                </a:solidFill>
-                <a:latin typeface="Rockwell" panose="02060603020205020403" pitchFamily="18" charset="0"/>
-              </a:rPr>
-              <a:t>VL53L8CX Driver Status</a:t>
-            </a:r>
-          </a:p>
-          <a:p>
-            <a:pPr algn="l">
-              <a:spcAft>
-                <a:spcPts val="300"/>
-              </a:spcAft>
-            </a:pPr>
-            <a:r>
-              <a:rPr sz="1050" b="0" dirty="0">
-                <a:solidFill>
-                  <a:srgbClr val="475569"/>
-                </a:solidFill>
-                <a:latin typeface="Rockwell" panose="02060603020205020403" pitchFamily="18" charset="0"/>
-              </a:rPr>
-              <a:t>Glue vs. vendor architecture, what's shipped, what's still open.</a:t>
-            </a:r>
-          </a:p>
-        </p:txBody>
-      </p:sp>
-      <p:sp>
-        <p:nvSpPr>
-          <p:cNvPr id="21" name="TextBox 20"/>
+                <a:spcPts val="0"/>
+              </a:spcAft>
+            </a:pPr>
+            <a:r>
+              <a:rPr sz="1600" b="1">
+                <a:latin typeface="Segoe UI"/>
+              </a:rPr>
+              <a:t>08</a:t>
+            </a:r>
+          </a:p>
+        </p:txBody>
+      </p:sp>
+      <p:sp>
+        <p:nvSpPr>
+          <p:cNvPr id="22" name="TextBox 21"/>
           <p:cNvSpPr txBox="1"/>
           <p:nvPr/>
         </p:nvSpPr>
         <p:spPr>
           <a:xfrm>
-            <a:off x="6217919" y="4800600"/>
-            <a:ext cx="731520" cy="1097280"/>
+            <a:off x="6949439" y="4846320"/>
+            <a:ext cx="4602479" cy="777136"/>
           </a:xfrm>
           <a:prstGeom prst="rect">
             <a:avLst/>
@@ -12963,73 +12038,46 @@
           <a:p>
             <a:pPr algn="l">
               <a:spcAft>
-                <a:spcPts val="0"/>
-              </a:spcAft>
-            </a:pPr>
-            <a:r>
-              <a:rPr sz="2000" b="1">
-                <a:solidFill>
-                  <a:srgbClr val="E2E8F0"/>
-                </a:solidFill>
-                <a:latin typeface="Segoe UI"/>
-              </a:rPr>
-              <a:t>08</a:t>
-            </a:r>
-          </a:p>
-        </p:txBody>
-      </p:sp>
-      <p:sp>
-        <p:nvSpPr>
-          <p:cNvPr id="22" name="TextBox 21"/>
-          <p:cNvSpPr txBox="1"/>
-          <p:nvPr/>
-        </p:nvSpPr>
-        <p:spPr>
-          <a:xfrm>
-            <a:off x="6949439" y="4846320"/>
-            <a:ext cx="4602479" cy="407804"/>
-          </a:xfrm>
-          <a:prstGeom prst="rect">
-            <a:avLst/>
-          </a:prstGeom>
-          <a:noFill/>
-        </p:spPr>
-        <p:txBody>
-          <a:bodyPr wrap="square" lIns="0" tIns="0" rIns="0" bIns="0">
-            <a:spAutoFit/>
-          </a:bodyPr>
-          <a:lstStyle/>
-          <a:p>
-            <a:pPr algn="l">
-              <a:spcAft>
                 <a:spcPts val="300"/>
               </a:spcAft>
             </a:pPr>
             <a:r>
-              <a:rPr sz="1350" b="1" dirty="0">
+              <a:rPr lang="en-GB" sz="1600" b="1" dirty="0">
                 <a:solidFill>
                   <a:srgbClr val="0F172A"/>
                 </a:solidFill>
                 <a:latin typeface="Rockwell" panose="02060603020205020403" pitchFamily="18" charset="0"/>
               </a:rPr>
-              <a:t>Roadmap &amp; Conclusion</a:t>
-            </a:r>
-          </a:p>
-          <a:p>
-            <a:pPr algn="l">
+              <a:t>Performance &amp; Next Steps</a:t>
+            </a:r>
+            <a:endParaRPr sz="1600" b="1" dirty="0">
+              <a:solidFill>
+                <a:srgbClr val="0F172A"/>
+              </a:solidFill>
+              <a:latin typeface="Rockwell" panose="02060603020205020403" pitchFamily="18" charset="0"/>
+            </a:endParaRPr>
+          </a:p>
+          <a:p>
+            <a:pPr>
               <a:spcAft>
                 <a:spcPts val="300"/>
               </a:spcAft>
             </a:pPr>
             <a:r>
-              <a:rPr sz="1050" b="0" dirty="0">
+              <a:rPr lang="en-US" sz="1600" dirty="0">
                 <a:solidFill>
                   <a:srgbClr val="475569"/>
                 </a:solidFill>
                 <a:latin typeface="Rockwell" panose="02060603020205020403" pitchFamily="18" charset="0"/>
               </a:rPr>
-              <a:t>Remaining steps to a clean, upstream-ready driver.</a:t>
-            </a:r>
+              <a:t>Performance considerations, current status, and the path forward.</a:t>
+            </a:r>
+            <a:endParaRPr sz="1600" dirty="0">
+              <a:solidFill>
+                <a:srgbClr val="475569"/>
+              </a:solidFill>
+              <a:latin typeface="Rockwell" panose="02060603020205020403" pitchFamily="18" charset="0"/>
+            </a:endParaRPr>
           </a:p>
         </p:txBody>
       </p:sp>
@@ -13067,7 +12115,7 @@
         <p:spPr>
           <a:xfrm>
             <a:off x="640080" y="548640"/>
-            <a:ext cx="10058400" cy="415498"/>
+            <a:ext cx="10058400" cy="492443"/>
           </a:xfrm>
           <a:prstGeom prst="rect">
             <a:avLst/>
@@ -13101,7 +12149,25 @@
                 </a:solidFill>
                 <a:latin typeface="Segoe UI"/>
               </a:rPr>
-              <a:t> is Zephyr?</a:t>
+              <a:t> is </a:t>
+            </a:r>
+            <a:r>
+              <a:rPr sz="3200" b="1" dirty="0">
+                <a:solidFill>
+                  <a:srgbClr val="0F172A"/>
+                </a:solidFill>
+                <a:latin typeface="Rockwell" panose="02060603020205020403" pitchFamily="18" charset="0"/>
+              </a:rPr>
+              <a:t>Zephyr</a:t>
+            </a:r>
+            <a:r>
+              <a:rPr sz="2700" b="1" dirty="0">
+                <a:solidFill>
+                  <a:srgbClr val="0F172A"/>
+                </a:solidFill>
+                <a:latin typeface="Segoe UI"/>
+              </a:rPr>
+              <a:t>?</a:t>
             </a:r>
           </a:p>
         </p:txBody>

</xml_diff>